<commit_message>
Expand MAUI module slides for student learning
</commit_message>
<xml_diff>
--- a/Presentations/Module_10_JSON_Persistence_Presentation.pptx
+++ b/Presentations/Module_10_JSON_Persistence_Presentation.pptx
@@ -2,25 +2,28 @@
 <file path=ppt/presentation.xml><?xml version="1.0" encoding="utf-8"?>
 <p:presentation xmlns:p="http://schemas.openxmlformats.org/presentationml/2006/main">
   <p:sldMasterIdLst>
-    <p:sldMasterId xmlns:r="http://schemas.openxmlformats.org/officeDocument/2006/relationships" id="2147483648" r:id="R9384ec34947f4816"/>
+    <p:sldMasterId xmlns:r="http://schemas.openxmlformats.org/officeDocument/2006/relationships" id="2147483648" r:id="R10fccd2279c14cf2"/>
   </p:sldMasterIdLst>
   <p:notesMasterIdLst>
-    <p:notesMasterId xmlns:r="http://schemas.openxmlformats.org/officeDocument/2006/relationships" r:id="Rbb73de8c6b75405d"/>
+    <p:notesMasterId xmlns:r="http://schemas.openxmlformats.org/officeDocument/2006/relationships" r:id="Re1ed8454208f4b5f"/>
   </p:notesMasterIdLst>
   <p:sldIdLst>
-    <p:sldId xmlns:r="http://schemas.openxmlformats.org/officeDocument/2006/relationships" id="256" r:id="R57867b87d4ef4291"/>
-    <p:sldId xmlns:r="http://schemas.openxmlformats.org/officeDocument/2006/relationships" id="257" r:id="R234a49285aef41ae"/>
-    <p:sldId xmlns:r="http://schemas.openxmlformats.org/officeDocument/2006/relationships" id="258" r:id="Rb830862c56074037"/>
-    <p:sldId xmlns:r="http://schemas.openxmlformats.org/officeDocument/2006/relationships" id="259" r:id="Re568ec5adfd04404"/>
-    <p:sldId xmlns:r="http://schemas.openxmlformats.org/officeDocument/2006/relationships" id="260" r:id="Rde28fd804a59470f"/>
-    <p:sldId xmlns:r="http://schemas.openxmlformats.org/officeDocument/2006/relationships" id="261" r:id="R6f8d9c138fcc4e40"/>
-    <p:sldId xmlns:r="http://schemas.openxmlformats.org/officeDocument/2006/relationships" id="262" r:id="R7b505f826f31432f"/>
-    <p:sldId xmlns:r="http://schemas.openxmlformats.org/officeDocument/2006/relationships" id="263" r:id="Re9a665e94f23452a"/>
-    <p:sldId xmlns:r="http://schemas.openxmlformats.org/officeDocument/2006/relationships" id="264" r:id="R0ef2e6f0f62c4bdc"/>
-    <p:sldId xmlns:r="http://schemas.openxmlformats.org/officeDocument/2006/relationships" id="265" r:id="R7e42e9e8ca6c425d"/>
-    <p:sldId xmlns:r="http://schemas.openxmlformats.org/officeDocument/2006/relationships" id="266" r:id="R2607da1e45574037"/>
-    <p:sldId xmlns:r="http://schemas.openxmlformats.org/officeDocument/2006/relationships" id="267" r:id="Re840db5752ff450d"/>
-    <p:sldId xmlns:r="http://schemas.openxmlformats.org/officeDocument/2006/relationships" id="268" r:id="R2c1931a09c7d4535"/>
+    <p:sldId xmlns:r="http://schemas.openxmlformats.org/officeDocument/2006/relationships" id="256" r:id="Ra7f42204831749df"/>
+    <p:sldId xmlns:r="http://schemas.openxmlformats.org/officeDocument/2006/relationships" id="257" r:id="R66acc1b50d804c67"/>
+    <p:sldId xmlns:r="http://schemas.openxmlformats.org/officeDocument/2006/relationships" id="258" r:id="R4f36a48d5c854002"/>
+    <p:sldId xmlns:r="http://schemas.openxmlformats.org/officeDocument/2006/relationships" id="259" r:id="R268f55012276492d"/>
+    <p:sldId xmlns:r="http://schemas.openxmlformats.org/officeDocument/2006/relationships" id="260" r:id="R6912380851fe4ab0"/>
+    <p:sldId xmlns:r="http://schemas.openxmlformats.org/officeDocument/2006/relationships" id="261" r:id="Rb5502a6255774556"/>
+    <p:sldId xmlns:r="http://schemas.openxmlformats.org/officeDocument/2006/relationships" id="262" r:id="R6921334ae5ca4c9f"/>
+    <p:sldId xmlns:r="http://schemas.openxmlformats.org/officeDocument/2006/relationships" id="263" r:id="R8faa51bc28794694"/>
+    <p:sldId xmlns:r="http://schemas.openxmlformats.org/officeDocument/2006/relationships" id="264" r:id="Rd150538a19cb494b"/>
+    <p:sldId xmlns:r="http://schemas.openxmlformats.org/officeDocument/2006/relationships" id="265" r:id="Rb7c90b5753824419"/>
+    <p:sldId xmlns:r="http://schemas.openxmlformats.org/officeDocument/2006/relationships" id="266" r:id="R994f42b2fa744904"/>
+    <p:sldId xmlns:r="http://schemas.openxmlformats.org/officeDocument/2006/relationships" id="267" r:id="R2edb66ec70df4e9b"/>
+    <p:sldId xmlns:r="http://schemas.openxmlformats.org/officeDocument/2006/relationships" id="268" r:id="R42b84cd99a2b4b6e"/>
+    <p:sldId xmlns:r="http://schemas.openxmlformats.org/officeDocument/2006/relationships" id="269" r:id="R40599bc7285d44c9"/>
+    <p:sldId xmlns:r="http://schemas.openxmlformats.org/officeDocument/2006/relationships" id="270" r:id="Rf427cc1eeea6431a"/>
+    <p:sldId xmlns:r="http://schemas.openxmlformats.org/officeDocument/2006/relationships" id="271" r:id="Rcd08a18ae9164fdc"/>
   </p:sldIdLst>
   <p:sldSz cx="12192000" cy="6858000"/>
   <p:notesSz cx="6858000" cy="9144000"/>
@@ -581,7 +584,7 @@
           <a:lstStyle xmlns:a="http://schemas.openxmlformats.org/drawingml/2006/main"/>
           <a:p xmlns:a="http://schemas.openxmlformats.org/drawingml/2006/main">
             <a:r>
-              <a:t>Introduce Module 10. Open the matching Word tutorial after the exercise overview.</a:t>
+              <a:t>Open the matching Word tutorial after the exercise overview. Source: Module 10 Word tutorial.</a:t>
             </a:r>
           </a:p>
         </p:txBody>
@@ -651,7 +654,7 @@
           <a:lstStyle xmlns:a="http://schemas.openxmlformats.org/drawingml/2006/main"/>
           <a:p xmlns:a="http://schemas.openxmlformats.org/drawingml/2006/main">
             <a:r>
-              <a:t>After tutorial Step 4: run the app or inspect the code. Ask students to explain the observed result. Source: Module 10 Word tutorial.</a:t>
+              <a:t>After tutorial Step 3: run the app or inspect the code. Ask students to explain the observed result. Source: Module 10 Word tutorial.</a:t>
             </a:r>
           </a:p>
         </p:txBody>
@@ -721,7 +724,7 @@
           <a:lstStyle xmlns:a="http://schemas.openxmlformats.org/drawingml/2006/main"/>
           <a:p xmlns:a="http://schemas.openxmlformats.org/drawingml/2006/main">
             <a:r>
-              <a:t>Before tutorial Step 5: explain these concepts. Ask students to predict what the change will do. Then open Step 5 in the Word tutorial. Source: Module 10 Word tutorial.</a:t>
+              <a:t>Before tutorial Step 4: explain these concepts. Ask students to predict what the change will do. Then open Step 4 in the Word tutorial. Source: Module 10 Word tutorial. Related MAUI documentation: https://learn.microsoft.com/dotnet/maui/platform-integration/storage/file-system-helpers</a:t>
             </a:r>
           </a:p>
         </p:txBody>
@@ -791,7 +794,7 @@
           <a:lstStyle xmlns:a="http://schemas.openxmlformats.org/drawingml/2006/main"/>
           <a:p xmlns:a="http://schemas.openxmlformats.org/drawingml/2006/main">
             <a:r>
-              <a:t>After tutorial Step 5: run the app or inspect the code. Ask students to explain the observed result. Source: Module 10 Word tutorial.</a:t>
+              <a:t>After tutorial Step 4: run the app or inspect the code. Ask students to explain the observed result. Source: Module 10 Word tutorial.</a:t>
             </a:r>
           </a:p>
         </p:txBody>
@@ -861,7 +864,217 @@
           <a:lstStyle xmlns:a="http://schemas.openxmlformats.org/drawingml/2006/main"/>
           <a:p xmlns:a="http://schemas.openxmlformats.org/drawingml/2006/main">
             <a:r>
+              <a:t>Before tutorial Step 5: explain these concepts. Ask students to predict what the change will do. Then open Step 5 in the Word tutorial. Source: Module 10 Word tutorial. Related MAUI documentation: https://learn.microsoft.com/dotnet/maui/platform-integration/storage/file-system-helpers</a:t>
+            </a:r>
+          </a:p>
+        </p:txBody>
+      </p:sp>
+      <p:sp>
+        <p:nvSpPr>
+          <p:cNvPr id="4" name="Slide Number Placeholder 3"/>
+          <p:cNvSpPr>
+            <a:spLocks xmlns:a="http://schemas.openxmlformats.org/drawingml/2006/main" noGrp="1"/>
+          </p:cNvSpPr>
+          <p:nvPr>
+            <p:ph type="sldNum" idx="5"/>
+          </p:nvPr>
+        </p:nvSpPr>
+        <p:spPr/>
+        <p:txBody>
+          <a:bodyPr xmlns:a="http://schemas.openxmlformats.org/drawingml/2006/main"/>
+          <a:lstStyle xmlns:a="http://schemas.openxmlformats.org/drawingml/2006/main"/>
+          <a:p xmlns:a="http://schemas.openxmlformats.org/drawingml/2006/main"/>
+        </p:txBody>
+      </p:sp>
+    </p:spTree>
+  </p:cSld>
+  <p:clrMapOvr>
+    <a:masterClrMapping xmlns:a="http://schemas.openxmlformats.org/drawingml/2006/main"/>
+  </p:clrMapOvr>
+</p:notes>
+</file>
+
+<file path=ppt/notesSlides/notesSlide14.xml><?xml version="1.0" encoding="utf-8"?>
+<p:notes xmlns:p="http://schemas.openxmlformats.org/presentationml/2006/main">
+  <p:cSld>
+    <p:spTree>
+      <p:nvGrpSpPr>
+        <p:cNvPr id="1" name=""/>
+        <p:cNvGrpSpPr/>
+        <p:nvPr/>
+      </p:nvGrpSpPr>
+      <p:grpSpPr>
+        <a:xfrm xmlns:a="http://schemas.openxmlformats.org/drawingml/2006/main"/>
+      </p:grpSpPr>
+      <p:sp>
+        <p:nvSpPr>
+          <p:cNvPr id="2" name="Slide Image Placeholder 1"/>
+          <p:cNvSpPr>
+            <a:spLocks xmlns:a="http://schemas.openxmlformats.org/drawingml/2006/main" noGrp="1"/>
+          </p:cNvSpPr>
+          <p:nvPr>
+            <p:ph type="sldImg" idx="0"/>
+          </p:nvPr>
+        </p:nvSpPr>
+        <p:spPr/>
+      </p:sp>
+      <p:sp>
+        <p:nvSpPr>
+          <p:cNvPr id="3" name="Notes Placeholder 2"/>
+          <p:cNvSpPr>
+            <a:spLocks xmlns:a="http://schemas.openxmlformats.org/drawingml/2006/main" noGrp="1"/>
+          </p:cNvSpPr>
+          <p:nvPr>
+            <p:ph type="body" idx="1"/>
+          </p:nvPr>
+        </p:nvSpPr>
+        <p:spPr/>
+        <p:txBody>
+          <a:bodyPr xmlns:a="http://schemas.openxmlformats.org/drawingml/2006/main"/>
+          <a:lstStyle xmlns:a="http://schemas.openxmlformats.org/drawingml/2006/main"/>
+          <a:p xmlns:a="http://schemas.openxmlformats.org/drawingml/2006/main">
+            <a:r>
+              <a:t>After tutorial Step 5: run the app or inspect the code. Ask students to explain the observed result. Source: Module 10 Word tutorial.</a:t>
+            </a:r>
+          </a:p>
+        </p:txBody>
+      </p:sp>
+      <p:sp>
+        <p:nvSpPr>
+          <p:cNvPr id="4" name="Slide Number Placeholder 3"/>
+          <p:cNvSpPr>
+            <a:spLocks xmlns:a="http://schemas.openxmlformats.org/drawingml/2006/main" noGrp="1"/>
+          </p:cNvSpPr>
+          <p:nvPr>
+            <p:ph type="sldNum" idx="5"/>
+          </p:nvPr>
+        </p:nvSpPr>
+        <p:spPr/>
+        <p:txBody>
+          <a:bodyPr xmlns:a="http://schemas.openxmlformats.org/drawingml/2006/main"/>
+          <a:lstStyle xmlns:a="http://schemas.openxmlformats.org/drawingml/2006/main"/>
+          <a:p xmlns:a="http://schemas.openxmlformats.org/drawingml/2006/main"/>
+        </p:txBody>
+      </p:sp>
+    </p:spTree>
+  </p:cSld>
+  <p:clrMapOvr>
+    <a:masterClrMapping xmlns:a="http://schemas.openxmlformats.org/drawingml/2006/main"/>
+  </p:clrMapOvr>
+</p:notes>
+</file>
+
+<file path=ppt/notesSlides/notesSlide15.xml><?xml version="1.0" encoding="utf-8"?>
+<p:notes xmlns:p="http://schemas.openxmlformats.org/presentationml/2006/main">
+  <p:cSld>
+    <p:spTree>
+      <p:nvGrpSpPr>
+        <p:cNvPr id="1" name=""/>
+        <p:cNvGrpSpPr/>
+        <p:nvPr/>
+      </p:nvGrpSpPr>
+      <p:grpSpPr>
+        <a:xfrm xmlns:a="http://schemas.openxmlformats.org/drawingml/2006/main"/>
+      </p:grpSpPr>
+      <p:sp>
+        <p:nvSpPr>
+          <p:cNvPr id="2" name="Slide Image Placeholder 1"/>
+          <p:cNvSpPr>
+            <a:spLocks xmlns:a="http://schemas.openxmlformats.org/drawingml/2006/main" noGrp="1"/>
+          </p:cNvSpPr>
+          <p:nvPr>
+            <p:ph type="sldImg" idx="0"/>
+          </p:nvPr>
+        </p:nvSpPr>
+        <p:spPr/>
+      </p:sp>
+      <p:sp>
+        <p:nvSpPr>
+          <p:cNvPr id="3" name="Notes Placeholder 2"/>
+          <p:cNvSpPr>
+            <a:spLocks xmlns:a="http://schemas.openxmlformats.org/drawingml/2006/main" noGrp="1"/>
+          </p:cNvSpPr>
+          <p:nvPr>
+            <p:ph type="body" idx="1"/>
+          </p:nvPr>
+        </p:nvSpPr>
+        <p:spPr/>
+        <p:txBody>
+          <a:bodyPr xmlns:a="http://schemas.openxmlformats.org/drawingml/2006/main"/>
+          <a:lstStyle xmlns:a="http://schemas.openxmlformats.org/drawingml/2006/main"/>
+          <a:p xmlns:a="http://schemas.openxmlformats.org/drawingml/2006/main">
+            <a:r>
               <a:t>Use the final tutorial checklist. Ask students to explain the module concept without reading code. Source: Module 10 Word tutorial.</a:t>
+            </a:r>
+          </a:p>
+        </p:txBody>
+      </p:sp>
+      <p:sp>
+        <p:nvSpPr>
+          <p:cNvPr id="4" name="Slide Number Placeholder 3"/>
+          <p:cNvSpPr>
+            <a:spLocks xmlns:a="http://schemas.openxmlformats.org/drawingml/2006/main" noGrp="1"/>
+          </p:cNvSpPr>
+          <p:nvPr>
+            <p:ph type="sldNum" idx="5"/>
+          </p:nvPr>
+        </p:nvSpPr>
+        <p:spPr/>
+        <p:txBody>
+          <a:bodyPr xmlns:a="http://schemas.openxmlformats.org/drawingml/2006/main"/>
+          <a:lstStyle xmlns:a="http://schemas.openxmlformats.org/drawingml/2006/main"/>
+          <a:p xmlns:a="http://schemas.openxmlformats.org/drawingml/2006/main"/>
+        </p:txBody>
+      </p:sp>
+    </p:spTree>
+  </p:cSld>
+  <p:clrMapOvr>
+    <a:masterClrMapping xmlns:a="http://schemas.openxmlformats.org/drawingml/2006/main"/>
+  </p:clrMapOvr>
+</p:notes>
+</file>
+
+<file path=ppt/notesSlides/notesSlide16.xml><?xml version="1.0" encoding="utf-8"?>
+<p:notes xmlns:p="http://schemas.openxmlformats.org/presentationml/2006/main">
+  <p:cSld>
+    <p:spTree>
+      <p:nvGrpSpPr>
+        <p:cNvPr id="1" name=""/>
+        <p:cNvGrpSpPr/>
+        <p:nvPr/>
+      </p:nvGrpSpPr>
+      <p:grpSpPr>
+        <a:xfrm xmlns:a="http://schemas.openxmlformats.org/drawingml/2006/main"/>
+      </p:grpSpPr>
+      <p:sp>
+        <p:nvSpPr>
+          <p:cNvPr id="2" name="Slide Image Placeholder 1"/>
+          <p:cNvSpPr>
+            <a:spLocks xmlns:a="http://schemas.openxmlformats.org/drawingml/2006/main" noGrp="1"/>
+          </p:cNvSpPr>
+          <p:nvPr>
+            <p:ph type="sldImg" idx="0"/>
+          </p:nvPr>
+        </p:nvSpPr>
+        <p:spPr/>
+      </p:sp>
+      <p:sp>
+        <p:nvSpPr>
+          <p:cNvPr id="3" name="Notes Placeholder 2"/>
+          <p:cNvSpPr>
+            <a:spLocks xmlns:a="http://schemas.openxmlformats.org/drawingml/2006/main" noGrp="1"/>
+          </p:cNvSpPr>
+          <p:nvPr>
+            <p:ph type="body" idx="1"/>
+          </p:nvPr>
+        </p:nvSpPr>
+        <p:spPr/>
+        <p:txBody>
+          <a:bodyPr xmlns:a="http://schemas.openxmlformats.org/drawingml/2006/main"/>
+          <a:lstStyle xmlns:a="http://schemas.openxmlformats.org/drawingml/2006/main"/>
+          <a:p xmlns:a="http://schemas.openxmlformats.org/drawingml/2006/main">
+            <a:r>
+              <a:t>Student reading: App data and file system. https://learn.microsoft.com/dotnet/maui/platform-integration/storage/file-system-helpers</a:t>
             </a:r>
           </a:p>
         </p:txBody>
@@ -931,7 +1144,7 @@
           <a:lstStyle xmlns:a="http://schemas.openxmlformats.org/drawingml/2006/main"/>
           <a:p xmlns:a="http://schemas.openxmlformats.org/drawingml/2006/main">
             <a:r>
-              <a:t>Explain the work for Module 10. Show the expected app result before students start. Source: Module 10 Word tutorial.</a:t>
+              <a:t>Give students the outcome before they start. Source: Module 10 Word tutorial.</a:t>
             </a:r>
           </a:p>
         </p:txBody>
@@ -1001,7 +1214,7 @@
           <a:lstStyle xmlns:a="http://schemas.openxmlformats.org/drawingml/2006/main"/>
           <a:p xmlns:a="http://schemas.openxmlformats.org/drawingml/2006/main">
             <a:r>
-              <a:t>Before tutorial Step 1: explain these concepts. Ask students to predict what the change will do. Then open Step 1 in the Word tutorial. Source: Module 10 Word tutorial.</a:t>
+              <a:t>Explain the framework idea before the first exercise step. MAUI documentation: https://learn.microsoft.com/dotnet/maui/platform-integration/storage/file-system-helpers</a:t>
             </a:r>
           </a:p>
         </p:txBody>
@@ -1071,7 +1284,7 @@
           <a:lstStyle xmlns:a="http://schemas.openxmlformats.org/drawingml/2006/main"/>
           <a:p xmlns:a="http://schemas.openxmlformats.org/drawingml/2006/main">
             <a:r>
-              <a:t>After tutorial Step 1: run the app or inspect the code. Ask students to explain the observed result. Source: Module 10 Word tutorial.</a:t>
+              <a:t>Ask students to identify the C# object, the XAML control, and the connection between them. Source: Module 10 Word tutorial. MAUI documentation: https://learn.microsoft.com/dotnet/maui/platform-integration/storage/file-system-helpers</a:t>
             </a:r>
           </a:p>
         </p:txBody>
@@ -1141,7 +1354,7 @@
           <a:lstStyle xmlns:a="http://schemas.openxmlformats.org/drawingml/2006/main"/>
           <a:p xmlns:a="http://schemas.openxmlformats.org/drawingml/2006/main">
             <a:r>
-              <a:t>Before tutorial Step 2: explain these concepts. Ask students to predict what the change will do. Then open Step 2 in the Word tutorial. Source: Module 10 Word tutorial.</a:t>
+              <a:t>Before tutorial Step 1: explain these concepts. Ask students to predict what the change will do. Then open Step 1 in the Word tutorial. Source: Module 10 Word tutorial. Related MAUI documentation: https://learn.microsoft.com/dotnet/maui/platform-integration/storage/file-system-helpers</a:t>
             </a:r>
           </a:p>
         </p:txBody>
@@ -1211,7 +1424,7 @@
           <a:lstStyle xmlns:a="http://schemas.openxmlformats.org/drawingml/2006/main"/>
           <a:p xmlns:a="http://schemas.openxmlformats.org/drawingml/2006/main">
             <a:r>
-              <a:t>After tutorial Step 2: run the app or inspect the code. Ask students to explain the observed result. Source: Module 10 Word tutorial.</a:t>
+              <a:t>After tutorial Step 1: run the app or inspect the code. Ask students to explain the observed result. Source: Module 10 Word tutorial.</a:t>
             </a:r>
           </a:p>
         </p:txBody>
@@ -1281,7 +1494,7 @@
           <a:lstStyle xmlns:a="http://schemas.openxmlformats.org/drawingml/2006/main"/>
           <a:p xmlns:a="http://schemas.openxmlformats.org/drawingml/2006/main">
             <a:r>
-              <a:t>Before tutorial Step 3: explain these concepts. Ask students to predict what the change will do. Then open Step 3 in the Word tutorial. Source: Module 10 Word tutorial.</a:t>
+              <a:t>Before tutorial Step 2: explain these concepts. Ask students to predict what the change will do. Then open Step 2 in the Word tutorial. Source: Module 10 Word tutorial. Related MAUI documentation: https://learn.microsoft.com/dotnet/maui/platform-integration/storage/file-system-helpers</a:t>
             </a:r>
           </a:p>
         </p:txBody>
@@ -1351,7 +1564,7 @@
           <a:lstStyle xmlns:a="http://schemas.openxmlformats.org/drawingml/2006/main"/>
           <a:p xmlns:a="http://schemas.openxmlformats.org/drawingml/2006/main">
             <a:r>
-              <a:t>After tutorial Step 3: run the app or inspect the code. Ask students to explain the observed result. Source: Module 10 Word tutorial.</a:t>
+              <a:t>After tutorial Step 2: run the app or inspect the code. Ask students to explain the observed result. Source: Module 10 Word tutorial.</a:t>
             </a:r>
           </a:p>
         </p:txBody>
@@ -1421,7 +1634,7 @@
           <a:lstStyle xmlns:a="http://schemas.openxmlformats.org/drawingml/2006/main"/>
           <a:p xmlns:a="http://schemas.openxmlformats.org/drawingml/2006/main">
             <a:r>
-              <a:t>Before tutorial Step 4: explain these concepts. Ask students to predict what the change will do. Then open Step 4 in the Word tutorial. Source: Module 10 Word tutorial.</a:t>
+              <a:t>Before tutorial Step 3: explain these concepts. Ask students to predict what the change will do. Then open Step 3 in the Word tutorial. Source: Module 10 Word tutorial. Related MAUI documentation: https://learn.microsoft.com/dotnet/maui/platform-integration/storage/file-system-helpers</a:t>
             </a:r>
           </a:p>
         </p:txBody>
@@ -1531,7 +1744,7 @@
           <p:cNvPr id="14" name="Picture 13">
             <a:extLst xmlns:a="http://schemas.openxmlformats.org/drawingml/2006/main">
               <a:ext uri="{FF2B5EF4-FFF2-40B4-BE49-F238E27FC236}">
-                <a16:creationId xmlns:a16="http://schemas.microsoft.com/office/drawing/2014/main" id="{9333950A-C79F-4D0C-BEF3-B477ADB582F8}"/>
+                <a16:creationId xmlns:a16="http://schemas.microsoft.com/office/drawing/2014/main" id="{159E8BE4-670B-424A-9736-DDC3C1A59B48}"/>
               </a:ext>
             </a:extLst>
           </p:cNvPr>
@@ -1541,7 +1754,7 @@
           <p:nvPr/>
         </p:nvPicPr>
         <p:blipFill>
-          <a:blip xmlns:r="http://schemas.openxmlformats.org/officeDocument/2006/relationships" xmlns:a="http://schemas.openxmlformats.org/drawingml/2006/main" r:embed="Rcc4bb3233a9e4a9e">
+          <a:blip xmlns:r="http://schemas.openxmlformats.org/officeDocument/2006/relationships" xmlns:a="http://schemas.openxmlformats.org/drawingml/2006/main" r:embed="R8fff7a39b7734584">
             <a:alphaModFix amt="40000"/>
           </a:blip>
           <a:stretch xmlns:a="http://schemas.openxmlformats.org/drawingml/2006/main">
@@ -1704,7 +1917,7 @@
           <p:cNvPr id="2" name="Title 1">
             <a:extLst xmlns:a="http://schemas.openxmlformats.org/drawingml/2006/main">
               <a:ext uri="{FF2B5EF4-FFF2-40B4-BE49-F238E27FC236}">
-                <a16:creationId xmlns:a16="http://schemas.microsoft.com/office/drawing/2014/main" id="{1A71403F-EC5C-4929-8E1C-DE0BD8E2D108}"/>
+                <a16:creationId xmlns:a16="http://schemas.microsoft.com/office/drawing/2014/main" id="{32A78BA0-24A5-4448-A3A8-4C52735BBBDF}"/>
               </a:ext>
             </a:extLst>
           </p:cNvPr>
@@ -1751,7 +1964,7 @@
           <p:cNvPr id="3" name="Subtitle 2">
             <a:extLst xmlns:a="http://schemas.openxmlformats.org/drawingml/2006/main">
               <a:ext uri="{FF2B5EF4-FFF2-40B4-BE49-F238E27FC236}">
-                <a16:creationId xmlns:a16="http://schemas.microsoft.com/office/drawing/2014/main" id="{9FC7538D-E37D-4789-87B2-6FBACA8166F1}"/>
+                <a16:creationId xmlns:a16="http://schemas.microsoft.com/office/drawing/2014/main" id="{E876C9BF-3ACE-47F5-BBFE-292F078F6330}"/>
               </a:ext>
             </a:extLst>
           </p:cNvPr>
@@ -1879,7 +2092,7 @@
           <p:cNvPr id="4" name="Date Placeholder 3">
             <a:extLst xmlns:a="http://schemas.openxmlformats.org/drawingml/2006/main">
               <a:ext uri="{FF2B5EF4-FFF2-40B4-BE49-F238E27FC236}">
-                <a16:creationId xmlns:a16="http://schemas.microsoft.com/office/drawing/2014/main" id="{4A717EDF-5FAA-4CD1-B8E1-D505727A63C5}"/>
+                <a16:creationId xmlns:a16="http://schemas.microsoft.com/office/drawing/2014/main" id="{DF731B35-321D-4CD9-B580-4549B9F51CDA}"/>
               </a:ext>
             </a:extLst>
           </p:cNvPr>
@@ -1907,7 +2120,7 @@
           <p:cNvPr id="5" name="Footer Placeholder 4">
             <a:extLst xmlns:a="http://schemas.openxmlformats.org/drawingml/2006/main">
               <a:ext uri="{FF2B5EF4-FFF2-40B4-BE49-F238E27FC236}">
-                <a16:creationId xmlns:a16="http://schemas.microsoft.com/office/drawing/2014/main" id="{5DA26104-98DD-4964-8BC6-98F2B4C00E15}"/>
+                <a16:creationId xmlns:a16="http://schemas.microsoft.com/office/drawing/2014/main" id="{4DC5B9AE-B6CD-461E-9578-4731560B01DC}"/>
               </a:ext>
             </a:extLst>
           </p:cNvPr>
@@ -1932,7 +2145,7 @@
           <p:cNvPr id="6" name="Slide Number Placeholder 5">
             <a:extLst xmlns:a="http://schemas.openxmlformats.org/drawingml/2006/main">
               <a:ext uri="{FF2B5EF4-FFF2-40B4-BE49-F238E27FC236}">
-                <a16:creationId xmlns:a16="http://schemas.microsoft.com/office/drawing/2014/main" id="{552F6DE3-5455-4D1B-A36F-6AED00EAE365}"/>
+                <a16:creationId xmlns:a16="http://schemas.microsoft.com/office/drawing/2014/main" id="{5BA4136A-E0D4-4802-8A1A-8741B6A4F3CC}"/>
               </a:ext>
             </a:extLst>
           </p:cNvPr>
@@ -2031,7 +2244,7 @@
           <p:cNvPr id="2" name="Title 1">
             <a:extLst xmlns:a="http://schemas.openxmlformats.org/drawingml/2006/main">
               <a:ext uri="{FF2B5EF4-FFF2-40B4-BE49-F238E27FC236}">
-                <a16:creationId xmlns:a16="http://schemas.microsoft.com/office/drawing/2014/main" id="{3F2562F4-F03A-44F8-A757-D6E3F2A0DCCF}"/>
+                <a16:creationId xmlns:a16="http://schemas.microsoft.com/office/drawing/2014/main" id="{2A314A09-4164-4BC8-B291-0B2C4E95E764}"/>
               </a:ext>
             </a:extLst>
           </p:cNvPr>
@@ -2058,7 +2271,7 @@
           <p:cNvPr id="3" name="Vertical Text Placeholder 2">
             <a:extLst xmlns:a="http://schemas.openxmlformats.org/drawingml/2006/main">
               <a:ext uri="{FF2B5EF4-FFF2-40B4-BE49-F238E27FC236}">
-                <a16:creationId xmlns:a16="http://schemas.microsoft.com/office/drawing/2014/main" id="{4BD58A74-98B4-4EE0-96B3-889A2F880640}"/>
+                <a16:creationId xmlns:a16="http://schemas.microsoft.com/office/drawing/2014/main" id="{11829508-09BD-4B32-B9FD-15003D5F4074}"/>
               </a:ext>
             </a:extLst>
           </p:cNvPr>
@@ -2120,7 +2333,7 @@
           <p:cNvPr id="4" name="Date Placeholder 3">
             <a:extLst xmlns:a="http://schemas.openxmlformats.org/drawingml/2006/main">
               <a:ext uri="{FF2B5EF4-FFF2-40B4-BE49-F238E27FC236}">
-                <a16:creationId xmlns:a16="http://schemas.microsoft.com/office/drawing/2014/main" id="{82E1343A-826F-4E82-B984-A1EC5AAAA2FB}"/>
+                <a16:creationId xmlns:a16="http://schemas.microsoft.com/office/drawing/2014/main" id="{D4C8DEAA-311D-4A83-A8F8-8BDB98F917AF}"/>
               </a:ext>
             </a:extLst>
           </p:cNvPr>
@@ -2148,7 +2361,7 @@
           <p:cNvPr id="5" name="Footer Placeholder 4">
             <a:extLst xmlns:a="http://schemas.openxmlformats.org/drawingml/2006/main">
               <a:ext uri="{FF2B5EF4-FFF2-40B4-BE49-F238E27FC236}">
-                <a16:creationId xmlns:a16="http://schemas.microsoft.com/office/drawing/2014/main" id="{10C600AF-3E3B-49AC-BC07-59F765BFFDEB}"/>
+                <a16:creationId xmlns:a16="http://schemas.microsoft.com/office/drawing/2014/main" id="{14F0A8DC-E3C7-4038-9938-815A4A8CC23E}"/>
               </a:ext>
             </a:extLst>
           </p:cNvPr>
@@ -2173,7 +2386,7 @@
           <p:cNvPr id="6" name="Slide Number Placeholder 5">
             <a:extLst xmlns:a="http://schemas.openxmlformats.org/drawingml/2006/main">
               <a:ext uri="{FF2B5EF4-FFF2-40B4-BE49-F238E27FC236}">
-                <a16:creationId xmlns:a16="http://schemas.microsoft.com/office/drawing/2014/main" id="{0827E458-5F28-4CC8-AC67-F66057356311}"/>
+                <a16:creationId xmlns:a16="http://schemas.microsoft.com/office/drawing/2014/main" id="{52C5B263-7215-43F5-9F73-363CC6A1204A}"/>
               </a:ext>
             </a:extLst>
           </p:cNvPr>
@@ -2218,7 +2431,7 @@
           <p:cNvPr id="2" name="Vertical Title 1">
             <a:extLst xmlns:a="http://schemas.openxmlformats.org/drawingml/2006/main">
               <a:ext uri="{FF2B5EF4-FFF2-40B4-BE49-F238E27FC236}">
-                <a16:creationId xmlns:a16="http://schemas.microsoft.com/office/drawing/2014/main" id="{5F717480-7855-4FF8-820D-F62DA2DB836D}"/>
+                <a16:creationId xmlns:a16="http://schemas.microsoft.com/office/drawing/2014/main" id="{67E502A9-4BCD-4D1E-92F2-16EDC38FC39F}"/>
               </a:ext>
             </a:extLst>
           </p:cNvPr>
@@ -2250,7 +2463,7 @@
           <p:cNvPr id="3" name="Vertical Text Placeholder 2">
             <a:extLst xmlns:a="http://schemas.openxmlformats.org/drawingml/2006/main">
               <a:ext uri="{FF2B5EF4-FFF2-40B4-BE49-F238E27FC236}">
-                <a16:creationId xmlns:a16="http://schemas.microsoft.com/office/drawing/2014/main" id="{8035C01C-EC96-48C3-BC55-D2165A5BD91B}"/>
+                <a16:creationId xmlns:a16="http://schemas.microsoft.com/office/drawing/2014/main" id="{8913061D-E2F4-47B4-B96F-BAFC35FDDD0C}"/>
               </a:ext>
             </a:extLst>
           </p:cNvPr>
@@ -2317,7 +2530,7 @@
           <p:cNvPr id="4" name="Date Placeholder 3">
             <a:extLst xmlns:a="http://schemas.openxmlformats.org/drawingml/2006/main">
               <a:ext uri="{FF2B5EF4-FFF2-40B4-BE49-F238E27FC236}">
-                <a16:creationId xmlns:a16="http://schemas.microsoft.com/office/drawing/2014/main" id="{C40EF4A5-5122-43C3-82FF-D05CD0A0B0C6}"/>
+                <a16:creationId xmlns:a16="http://schemas.microsoft.com/office/drawing/2014/main" id="{C9C55F28-A0B4-453B-94AE-A63981924FD5}"/>
               </a:ext>
             </a:extLst>
           </p:cNvPr>
@@ -2345,7 +2558,7 @@
           <p:cNvPr id="5" name="Footer Placeholder 4">
             <a:extLst xmlns:a="http://schemas.openxmlformats.org/drawingml/2006/main">
               <a:ext uri="{FF2B5EF4-FFF2-40B4-BE49-F238E27FC236}">
-                <a16:creationId xmlns:a16="http://schemas.microsoft.com/office/drawing/2014/main" id="{D43850DD-8F47-4C6F-B8E8-25518F3BDFF9}"/>
+                <a16:creationId xmlns:a16="http://schemas.microsoft.com/office/drawing/2014/main" id="{6BAA17DF-E532-4102-9E84-7C56AA807960}"/>
               </a:ext>
             </a:extLst>
           </p:cNvPr>
@@ -2370,7 +2583,7 @@
           <p:cNvPr id="6" name="Slide Number Placeholder 5">
             <a:extLst xmlns:a="http://schemas.openxmlformats.org/drawingml/2006/main">
               <a:ext uri="{FF2B5EF4-FFF2-40B4-BE49-F238E27FC236}">
-                <a16:creationId xmlns:a16="http://schemas.microsoft.com/office/drawing/2014/main" id="{00802AEC-1C85-4A44-B3EB-01D104097458}"/>
+                <a16:creationId xmlns:a16="http://schemas.microsoft.com/office/drawing/2014/main" id="{B4EDAE0B-BD68-4913-803D-7B1446BAA039}"/>
               </a:ext>
             </a:extLst>
           </p:cNvPr>
@@ -2415,7 +2628,7 @@
           <p:cNvPr id="3" name="Content Placeholder 2">
             <a:extLst xmlns:a="http://schemas.openxmlformats.org/drawingml/2006/main">
               <a:ext uri="{FF2B5EF4-FFF2-40B4-BE49-F238E27FC236}">
-                <a16:creationId xmlns:a16="http://schemas.microsoft.com/office/drawing/2014/main" id="{D8514CD9-F679-4F74-B9A7-3E0301EE9BCF}"/>
+                <a16:creationId xmlns:a16="http://schemas.microsoft.com/office/drawing/2014/main" id="{EB77854E-AE38-4EF5-B06D-8B262A2FE515}"/>
               </a:ext>
             </a:extLst>
           </p:cNvPr>
@@ -2478,7 +2691,7 @@
           <p:cNvPr id="4" name="Date Placeholder 3">
             <a:extLst xmlns:a="http://schemas.openxmlformats.org/drawingml/2006/main">
               <a:ext uri="{FF2B5EF4-FFF2-40B4-BE49-F238E27FC236}">
-                <a16:creationId xmlns:a16="http://schemas.microsoft.com/office/drawing/2014/main" id="{DFA04C11-D16A-4BC4-B5FB-700AB967EC8D}"/>
+                <a16:creationId xmlns:a16="http://schemas.microsoft.com/office/drawing/2014/main" id="{45851901-088A-4420-8036-0E4BCEE7804F}"/>
               </a:ext>
             </a:extLst>
           </p:cNvPr>
@@ -2506,7 +2719,7 @@
           <p:cNvPr id="5" name="Footer Placeholder 4">
             <a:extLst xmlns:a="http://schemas.openxmlformats.org/drawingml/2006/main">
               <a:ext uri="{FF2B5EF4-FFF2-40B4-BE49-F238E27FC236}">
-                <a16:creationId xmlns:a16="http://schemas.microsoft.com/office/drawing/2014/main" id="{98961292-A1F3-4CCD-978A-1082A52ECEF2}"/>
+                <a16:creationId xmlns:a16="http://schemas.microsoft.com/office/drawing/2014/main" id="{B7AA982D-A9D8-4295-9F22-70A9DC6D3EE9}"/>
               </a:ext>
             </a:extLst>
           </p:cNvPr>
@@ -2531,7 +2744,7 @@
           <p:cNvPr id="6" name="Slide Number Placeholder 5">
             <a:extLst xmlns:a="http://schemas.openxmlformats.org/drawingml/2006/main">
               <a:ext uri="{FF2B5EF4-FFF2-40B4-BE49-F238E27FC236}">
-                <a16:creationId xmlns:a16="http://schemas.microsoft.com/office/drawing/2014/main" id="{5A323583-89DC-44A7-B605-806EBE8918DE}"/>
+                <a16:creationId xmlns:a16="http://schemas.microsoft.com/office/drawing/2014/main" id="{C4A0F94D-DF46-4983-8088-1E06810933F5}"/>
               </a:ext>
             </a:extLst>
           </p:cNvPr>
@@ -2619,7 +2832,7 @@
           <p:cNvPr id="2" name="Title 1">
             <a:extLst xmlns:a="http://schemas.openxmlformats.org/drawingml/2006/main">
               <a:ext uri="{FF2B5EF4-FFF2-40B4-BE49-F238E27FC236}">
-                <a16:creationId xmlns:a16="http://schemas.microsoft.com/office/drawing/2014/main" id="{50C7C628-0AAB-49AB-BE88-61E915F715DD}"/>
+                <a16:creationId xmlns:a16="http://schemas.microsoft.com/office/drawing/2014/main" id="{1312108B-2D88-4799-9374-F2890E2901A1}"/>
               </a:ext>
             </a:extLst>
           </p:cNvPr>
@@ -2657,7 +2870,7 @@
           <p:cNvPr id="3" name="Text Placeholder 2">
             <a:extLst xmlns:a="http://schemas.openxmlformats.org/drawingml/2006/main">
               <a:ext uri="{FF2B5EF4-FFF2-40B4-BE49-F238E27FC236}">
-                <a16:creationId xmlns:a16="http://schemas.microsoft.com/office/drawing/2014/main" id="{B85A2D5B-A526-45F2-8A90-475080A07510}"/>
+                <a16:creationId xmlns:a16="http://schemas.microsoft.com/office/drawing/2014/main" id="{9E976370-D4C5-47F4-A13C-AD2EAF21C43A}"/>
               </a:ext>
             </a:extLst>
           </p:cNvPr>
@@ -2783,7 +2996,7 @@
           <p:cNvPr id="4" name="Date Placeholder 3">
             <a:extLst xmlns:a="http://schemas.openxmlformats.org/drawingml/2006/main">
               <a:ext uri="{FF2B5EF4-FFF2-40B4-BE49-F238E27FC236}">
-                <a16:creationId xmlns:a16="http://schemas.microsoft.com/office/drawing/2014/main" id="{E7F43A5E-71A1-48CE-97A4-E7C035D2930A}"/>
+                <a16:creationId xmlns:a16="http://schemas.microsoft.com/office/drawing/2014/main" id="{1DAB5508-0590-4D1C-B067-AC09BE933061}"/>
               </a:ext>
             </a:extLst>
           </p:cNvPr>
@@ -2811,7 +3024,7 @@
           <p:cNvPr id="5" name="Footer Placeholder 4">
             <a:extLst xmlns:a="http://schemas.openxmlformats.org/drawingml/2006/main">
               <a:ext uri="{FF2B5EF4-FFF2-40B4-BE49-F238E27FC236}">
-                <a16:creationId xmlns:a16="http://schemas.microsoft.com/office/drawing/2014/main" id="{B28A535D-A643-4B75-A49C-7F7F707561CF}"/>
+                <a16:creationId xmlns:a16="http://schemas.microsoft.com/office/drawing/2014/main" id="{68CE0EA3-795E-4350-88FF-2442DD760D72}"/>
               </a:ext>
             </a:extLst>
           </p:cNvPr>
@@ -2836,7 +3049,7 @@
           <p:cNvPr id="6" name="Slide Number Placeholder 5">
             <a:extLst xmlns:a="http://schemas.openxmlformats.org/drawingml/2006/main">
               <a:ext uri="{FF2B5EF4-FFF2-40B4-BE49-F238E27FC236}">
-                <a16:creationId xmlns:a16="http://schemas.microsoft.com/office/drawing/2014/main" id="{D940F10B-3A96-4A44-9EA6-792C11E9E503}"/>
+                <a16:creationId xmlns:a16="http://schemas.microsoft.com/office/drawing/2014/main" id="{CA69CF30-5A86-4CC1-B3BB-2037DBEFE04F}"/>
               </a:ext>
             </a:extLst>
           </p:cNvPr>
@@ -2881,7 +3094,7 @@
           <p:cNvPr id="2" name="Title 1">
             <a:extLst xmlns:a="http://schemas.openxmlformats.org/drawingml/2006/main">
               <a:ext uri="{FF2B5EF4-FFF2-40B4-BE49-F238E27FC236}">
-                <a16:creationId xmlns:a16="http://schemas.microsoft.com/office/drawing/2014/main" id="{04A276E9-58CB-4CC4-893F-7A322DE43E8A}"/>
+                <a16:creationId xmlns:a16="http://schemas.microsoft.com/office/drawing/2014/main" id="{374D3651-7AA0-4DA4-8052-C8365BBC5939}"/>
               </a:ext>
             </a:extLst>
           </p:cNvPr>
@@ -2908,7 +3121,7 @@
           <p:cNvPr id="3" name="Content Placeholder 2">
             <a:extLst xmlns:a="http://schemas.openxmlformats.org/drawingml/2006/main">
               <a:ext uri="{FF2B5EF4-FFF2-40B4-BE49-F238E27FC236}">
-                <a16:creationId xmlns:a16="http://schemas.microsoft.com/office/drawing/2014/main" id="{ED43BDDA-A767-43C4-884C-962AF910D276}"/>
+                <a16:creationId xmlns:a16="http://schemas.microsoft.com/office/drawing/2014/main" id="{0ACF48B1-0AF1-4DC7-953B-7CAC6EF7FD4A}"/>
               </a:ext>
             </a:extLst>
           </p:cNvPr>
@@ -3013,7 +3226,7 @@
           <p:cNvPr id="4" name="Content Placeholder 3">
             <a:extLst xmlns:a="http://schemas.openxmlformats.org/drawingml/2006/main">
               <a:ext uri="{FF2B5EF4-FFF2-40B4-BE49-F238E27FC236}">
-                <a16:creationId xmlns:a16="http://schemas.microsoft.com/office/drawing/2014/main" id="{B84517D9-5D03-4BF8-B44C-37C396C7B7A7}"/>
+                <a16:creationId xmlns:a16="http://schemas.microsoft.com/office/drawing/2014/main" id="{47BA981E-9181-49D3-997F-8A5023A3F699}"/>
               </a:ext>
             </a:extLst>
           </p:cNvPr>
@@ -3118,7 +3331,7 @@
           <p:cNvPr id="5" name="Date Placeholder 4">
             <a:extLst xmlns:a="http://schemas.openxmlformats.org/drawingml/2006/main">
               <a:ext uri="{FF2B5EF4-FFF2-40B4-BE49-F238E27FC236}">
-                <a16:creationId xmlns:a16="http://schemas.microsoft.com/office/drawing/2014/main" id="{DE91ABAC-036A-42C4-941B-290F35AB7930}"/>
+                <a16:creationId xmlns:a16="http://schemas.microsoft.com/office/drawing/2014/main" id="{54F8AD60-2841-4DC1-8AD1-9C7711F2B395}"/>
               </a:ext>
             </a:extLst>
           </p:cNvPr>
@@ -3146,7 +3359,7 @@
           <p:cNvPr id="6" name="Footer Placeholder 5">
             <a:extLst xmlns:a="http://schemas.openxmlformats.org/drawingml/2006/main">
               <a:ext uri="{FF2B5EF4-FFF2-40B4-BE49-F238E27FC236}">
-                <a16:creationId xmlns:a16="http://schemas.microsoft.com/office/drawing/2014/main" id="{2C791955-8E7A-4AB3-85DD-C03543A62CC3}"/>
+                <a16:creationId xmlns:a16="http://schemas.microsoft.com/office/drawing/2014/main" id="{B34E2BD6-3A75-4788-B617-75A60F64C4A8}"/>
               </a:ext>
             </a:extLst>
           </p:cNvPr>
@@ -3171,7 +3384,7 @@
           <p:cNvPr id="7" name="Slide Number Placeholder 6">
             <a:extLst xmlns:a="http://schemas.openxmlformats.org/drawingml/2006/main">
               <a:ext uri="{FF2B5EF4-FFF2-40B4-BE49-F238E27FC236}">
-                <a16:creationId xmlns:a16="http://schemas.microsoft.com/office/drawing/2014/main" id="{118B6D50-0971-48D2-A76C-9CEE4776E720}"/>
+                <a16:creationId xmlns:a16="http://schemas.microsoft.com/office/drawing/2014/main" id="{9B3FE306-693E-43F6-9AEC-2BD534EBCA19}"/>
               </a:ext>
             </a:extLst>
           </p:cNvPr>
@@ -3216,7 +3429,7 @@
           <p:cNvPr id="2" name="Title 1">
             <a:extLst xmlns:a="http://schemas.openxmlformats.org/drawingml/2006/main">
               <a:ext uri="{FF2B5EF4-FFF2-40B4-BE49-F238E27FC236}">
-                <a16:creationId xmlns:a16="http://schemas.microsoft.com/office/drawing/2014/main" id="{9F63C7DB-B3B4-4C10-919C-8AC08C4AA4C6}"/>
+                <a16:creationId xmlns:a16="http://schemas.microsoft.com/office/drawing/2014/main" id="{DD0D1872-CDC6-4FE2-9ABC-7B4228490905}"/>
               </a:ext>
             </a:extLst>
           </p:cNvPr>
@@ -3248,7 +3461,7 @@
           <p:cNvPr id="3" name="Text Placeholder 2">
             <a:extLst xmlns:a="http://schemas.openxmlformats.org/drawingml/2006/main">
               <a:ext uri="{FF2B5EF4-FFF2-40B4-BE49-F238E27FC236}">
-                <a16:creationId xmlns:a16="http://schemas.microsoft.com/office/drawing/2014/main" id="{B95A773F-B3F8-43E0-ADDD-0408DFCA6E8E}"/>
+                <a16:creationId xmlns:a16="http://schemas.microsoft.com/office/drawing/2014/main" id="{027FE125-A998-4205-9D00-6AA01C9BFFA7}"/>
               </a:ext>
             </a:extLst>
           </p:cNvPr>
@@ -3320,7 +3533,7 @@
           <p:cNvPr id="4" name="Content Placeholder 3">
             <a:extLst xmlns:a="http://schemas.openxmlformats.org/drawingml/2006/main">
               <a:ext uri="{FF2B5EF4-FFF2-40B4-BE49-F238E27FC236}">
-                <a16:creationId xmlns:a16="http://schemas.microsoft.com/office/drawing/2014/main" id="{728DF0DA-68B8-41E1-BA4A-8FE0CC616666}"/>
+                <a16:creationId xmlns:a16="http://schemas.microsoft.com/office/drawing/2014/main" id="{20BCD7A8-045A-4A8F-9312-AEF03CCFDED2}"/>
               </a:ext>
             </a:extLst>
           </p:cNvPr>
@@ -3424,7 +3637,7 @@
           <p:cNvPr id="5" name="Text Placeholder 4">
             <a:extLst xmlns:a="http://schemas.openxmlformats.org/drawingml/2006/main">
               <a:ext uri="{FF2B5EF4-FFF2-40B4-BE49-F238E27FC236}">
-                <a16:creationId xmlns:a16="http://schemas.microsoft.com/office/drawing/2014/main" id="{F538885A-D96F-4C46-8699-8E9750854FB8}"/>
+                <a16:creationId xmlns:a16="http://schemas.microsoft.com/office/drawing/2014/main" id="{784029EF-3E73-4ACD-B098-E68A551C63AB}"/>
               </a:ext>
             </a:extLst>
           </p:cNvPr>
@@ -3496,7 +3709,7 @@
           <p:cNvPr id="6" name="Content Placeholder 5">
             <a:extLst xmlns:a="http://schemas.openxmlformats.org/drawingml/2006/main">
               <a:ext uri="{FF2B5EF4-FFF2-40B4-BE49-F238E27FC236}">
-                <a16:creationId xmlns:a16="http://schemas.microsoft.com/office/drawing/2014/main" id="{0D702FB7-C287-4FDC-86E3-61B13416C6C1}"/>
+                <a16:creationId xmlns:a16="http://schemas.microsoft.com/office/drawing/2014/main" id="{4555D65D-45A0-4954-B970-ADC9871517CF}"/>
               </a:ext>
             </a:extLst>
           </p:cNvPr>
@@ -3600,7 +3813,7 @@
           <p:cNvPr id="7" name="Date Placeholder 6">
             <a:extLst xmlns:a="http://schemas.openxmlformats.org/drawingml/2006/main">
               <a:ext uri="{FF2B5EF4-FFF2-40B4-BE49-F238E27FC236}">
-                <a16:creationId xmlns:a16="http://schemas.microsoft.com/office/drawing/2014/main" id="{3D79FC36-4CBD-42F1-BD2C-538EAF4E7F12}"/>
+                <a16:creationId xmlns:a16="http://schemas.microsoft.com/office/drawing/2014/main" id="{6EB702A1-FFCF-40F0-BD65-67CF4D6E7F71}"/>
               </a:ext>
             </a:extLst>
           </p:cNvPr>
@@ -3628,7 +3841,7 @@
           <p:cNvPr id="8" name="Footer Placeholder 7">
             <a:extLst xmlns:a="http://schemas.openxmlformats.org/drawingml/2006/main">
               <a:ext uri="{FF2B5EF4-FFF2-40B4-BE49-F238E27FC236}">
-                <a16:creationId xmlns:a16="http://schemas.microsoft.com/office/drawing/2014/main" id="{0AA5D2C3-0DC8-4CB3-9F41-94E3D0321DD4}"/>
+                <a16:creationId xmlns:a16="http://schemas.microsoft.com/office/drawing/2014/main" id="{E2F61F0F-3C99-4F05-AEFE-BA5B9D1090EE}"/>
               </a:ext>
             </a:extLst>
           </p:cNvPr>
@@ -3653,7 +3866,7 @@
           <p:cNvPr id="9" name="Slide Number Placeholder 8">
             <a:extLst xmlns:a="http://schemas.openxmlformats.org/drawingml/2006/main">
               <a:ext uri="{FF2B5EF4-FFF2-40B4-BE49-F238E27FC236}">
-                <a16:creationId xmlns:a16="http://schemas.microsoft.com/office/drawing/2014/main" id="{820DB3D6-2B10-4907-AA3A-670A4F64E910}"/>
+                <a16:creationId xmlns:a16="http://schemas.microsoft.com/office/drawing/2014/main" id="{EA7623BE-FE7D-4E34-A19C-C1614737754E}"/>
               </a:ext>
             </a:extLst>
           </p:cNvPr>
@@ -3698,7 +3911,7 @@
           <p:cNvPr id="2" name="Title 1">
             <a:extLst xmlns:a="http://schemas.openxmlformats.org/drawingml/2006/main">
               <a:ext uri="{FF2B5EF4-FFF2-40B4-BE49-F238E27FC236}">
-                <a16:creationId xmlns:a16="http://schemas.microsoft.com/office/drawing/2014/main" id="{56889EBE-CBBA-4AC0-B576-B3F52DFA174F}"/>
+                <a16:creationId xmlns:a16="http://schemas.microsoft.com/office/drawing/2014/main" id="{4874290B-AC9C-4883-B886-6B85A114F133}"/>
               </a:ext>
             </a:extLst>
           </p:cNvPr>
@@ -3725,7 +3938,7 @@
           <p:cNvPr id="3" name="Date Placeholder 2">
             <a:extLst xmlns:a="http://schemas.openxmlformats.org/drawingml/2006/main">
               <a:ext uri="{FF2B5EF4-FFF2-40B4-BE49-F238E27FC236}">
-                <a16:creationId xmlns:a16="http://schemas.microsoft.com/office/drawing/2014/main" id="{D731B153-8D21-414F-A6DA-188B5F4BD1E7}"/>
+                <a16:creationId xmlns:a16="http://schemas.microsoft.com/office/drawing/2014/main" id="{BF2DB91C-1E45-46A0-AC21-559351D3B259}"/>
               </a:ext>
             </a:extLst>
           </p:cNvPr>
@@ -3753,7 +3966,7 @@
           <p:cNvPr id="4" name="Footer Placeholder 3">
             <a:extLst xmlns:a="http://schemas.openxmlformats.org/drawingml/2006/main">
               <a:ext uri="{FF2B5EF4-FFF2-40B4-BE49-F238E27FC236}">
-                <a16:creationId xmlns:a16="http://schemas.microsoft.com/office/drawing/2014/main" id="{04C9E04A-FD2F-4681-8860-7098598FF3C3}"/>
+                <a16:creationId xmlns:a16="http://schemas.microsoft.com/office/drawing/2014/main" id="{A6AE6637-74D6-4226-BB5F-2EB55221606B}"/>
               </a:ext>
             </a:extLst>
           </p:cNvPr>
@@ -3778,7 +3991,7 @@
           <p:cNvPr id="5" name="Slide Number Placeholder 4">
             <a:extLst xmlns:a="http://schemas.openxmlformats.org/drawingml/2006/main">
               <a:ext uri="{FF2B5EF4-FFF2-40B4-BE49-F238E27FC236}">
-                <a16:creationId xmlns:a16="http://schemas.microsoft.com/office/drawing/2014/main" id="{7A0357F5-D93C-4D5F-9630-56FA349BA104}"/>
+                <a16:creationId xmlns:a16="http://schemas.microsoft.com/office/drawing/2014/main" id="{C75FDF0B-456A-472C-810D-09A38999687A}"/>
               </a:ext>
             </a:extLst>
           </p:cNvPr>
@@ -3823,7 +4036,7 @@
           <p:cNvPr id="2" name="Date Placeholder 1">
             <a:extLst xmlns:a="http://schemas.openxmlformats.org/drawingml/2006/main">
               <a:ext uri="{FF2B5EF4-FFF2-40B4-BE49-F238E27FC236}">
-                <a16:creationId xmlns:a16="http://schemas.microsoft.com/office/drawing/2014/main" id="{02091434-41E8-4E7E-8F92-0D75DFF50DB5}"/>
+                <a16:creationId xmlns:a16="http://schemas.microsoft.com/office/drawing/2014/main" id="{910AA715-4551-49DE-96D9-FF4396B4380C}"/>
               </a:ext>
             </a:extLst>
           </p:cNvPr>
@@ -3851,7 +4064,7 @@
           <p:cNvPr id="3" name="Footer Placeholder 2">
             <a:extLst xmlns:a="http://schemas.openxmlformats.org/drawingml/2006/main">
               <a:ext uri="{FF2B5EF4-FFF2-40B4-BE49-F238E27FC236}">
-                <a16:creationId xmlns:a16="http://schemas.microsoft.com/office/drawing/2014/main" id="{49D14AE4-C238-49EC-9AF7-90FB6AF63555}"/>
+                <a16:creationId xmlns:a16="http://schemas.microsoft.com/office/drawing/2014/main" id="{95FA5A8F-6056-4DCC-8F29-3751F63984D9}"/>
               </a:ext>
             </a:extLst>
           </p:cNvPr>
@@ -3876,7 +4089,7 @@
           <p:cNvPr id="4" name="Slide Number Placeholder 3">
             <a:extLst xmlns:a="http://schemas.openxmlformats.org/drawingml/2006/main">
               <a:ext uri="{FF2B5EF4-FFF2-40B4-BE49-F238E27FC236}">
-                <a16:creationId xmlns:a16="http://schemas.microsoft.com/office/drawing/2014/main" id="{2454927F-B5BB-4496-B744-F8AF8FEF57F1}"/>
+                <a16:creationId xmlns:a16="http://schemas.microsoft.com/office/drawing/2014/main" id="{0CDCCF4F-5142-40BF-96F1-31530AD738EE}"/>
               </a:ext>
             </a:extLst>
           </p:cNvPr>
@@ -3921,7 +4134,7 @@
           <p:cNvPr id="2" name="Title 1">
             <a:extLst xmlns:a="http://schemas.openxmlformats.org/drawingml/2006/main">
               <a:ext uri="{FF2B5EF4-FFF2-40B4-BE49-F238E27FC236}">
-                <a16:creationId xmlns:a16="http://schemas.microsoft.com/office/drawing/2014/main" id="{73F82BF4-1D18-466E-8399-94D726496152}"/>
+                <a16:creationId xmlns:a16="http://schemas.microsoft.com/office/drawing/2014/main" id="{F40EACC5-7BA6-448D-8E57-EA7110CBE261}"/>
               </a:ext>
             </a:extLst>
           </p:cNvPr>
@@ -3958,7 +4171,7 @@
           <p:cNvPr id="3" name="Content Placeholder 2">
             <a:extLst xmlns:a="http://schemas.openxmlformats.org/drawingml/2006/main">
               <a:ext uri="{FF2B5EF4-FFF2-40B4-BE49-F238E27FC236}">
-                <a16:creationId xmlns:a16="http://schemas.microsoft.com/office/drawing/2014/main" id="{40BE39BC-27F9-4C3C-87B9-9DA29F94F0CE}"/>
+                <a16:creationId xmlns:a16="http://schemas.microsoft.com/office/drawing/2014/main" id="{A9B1A3CD-7DC2-44E3-B120-2B7D6A81AD00}"/>
               </a:ext>
             </a:extLst>
           </p:cNvPr>
@@ -4062,7 +4275,7 @@
           <p:cNvPr id="4" name="Text Placeholder 3">
             <a:extLst xmlns:a="http://schemas.openxmlformats.org/drawingml/2006/main">
               <a:ext uri="{FF2B5EF4-FFF2-40B4-BE49-F238E27FC236}">
-                <a16:creationId xmlns:a16="http://schemas.microsoft.com/office/drawing/2014/main" id="{1C93194F-18E2-499C-8F3A-6AA813AE65CC}"/>
+                <a16:creationId xmlns:a16="http://schemas.microsoft.com/office/drawing/2014/main" id="{981DF977-E2E9-4B33-86FA-7775184CC47B}"/>
               </a:ext>
             </a:extLst>
           </p:cNvPr>
@@ -4134,7 +4347,7 @@
           <p:cNvPr id="5" name="Date Placeholder 4">
             <a:extLst xmlns:a="http://schemas.openxmlformats.org/drawingml/2006/main">
               <a:ext uri="{FF2B5EF4-FFF2-40B4-BE49-F238E27FC236}">
-                <a16:creationId xmlns:a16="http://schemas.microsoft.com/office/drawing/2014/main" id="{FCFC45EB-330C-49C7-8C49-9C778FEAFB0D}"/>
+                <a16:creationId xmlns:a16="http://schemas.microsoft.com/office/drawing/2014/main" id="{25325E88-57CA-4EFA-B371-EF26193CDC52}"/>
               </a:ext>
             </a:extLst>
           </p:cNvPr>
@@ -4162,7 +4375,7 @@
           <p:cNvPr id="6" name="Footer Placeholder 5">
             <a:extLst xmlns:a="http://schemas.openxmlformats.org/drawingml/2006/main">
               <a:ext uri="{FF2B5EF4-FFF2-40B4-BE49-F238E27FC236}">
-                <a16:creationId xmlns:a16="http://schemas.microsoft.com/office/drawing/2014/main" id="{8AB44EAC-6E43-4851-AE52-8FBD866B85CE}"/>
+                <a16:creationId xmlns:a16="http://schemas.microsoft.com/office/drawing/2014/main" id="{ECF7D240-A166-4EF6-ABA9-7D10411A31A8}"/>
               </a:ext>
             </a:extLst>
           </p:cNvPr>
@@ -4187,7 +4400,7 @@
           <p:cNvPr id="7" name="Slide Number Placeholder 6">
             <a:extLst xmlns:a="http://schemas.openxmlformats.org/drawingml/2006/main">
               <a:ext uri="{FF2B5EF4-FFF2-40B4-BE49-F238E27FC236}">
-                <a16:creationId xmlns:a16="http://schemas.microsoft.com/office/drawing/2014/main" id="{3B3E460A-4318-4DB3-A16D-FD045F16FFD4}"/>
+                <a16:creationId xmlns:a16="http://schemas.microsoft.com/office/drawing/2014/main" id="{302BEF10-8329-4BEB-8B7A-3E68C57905EC}"/>
               </a:ext>
             </a:extLst>
           </p:cNvPr>
@@ -4232,7 +4445,7 @@
           <p:cNvPr id="2" name="Title 1">
             <a:extLst xmlns:a="http://schemas.openxmlformats.org/drawingml/2006/main">
               <a:ext uri="{FF2B5EF4-FFF2-40B4-BE49-F238E27FC236}">
-                <a16:creationId xmlns:a16="http://schemas.microsoft.com/office/drawing/2014/main" id="{77954AC7-5514-4159-BC8C-D089B9EE6C64}"/>
+                <a16:creationId xmlns:a16="http://schemas.microsoft.com/office/drawing/2014/main" id="{40A47EA5-2D5F-4CCD-8201-6399E0C934E6}"/>
               </a:ext>
             </a:extLst>
           </p:cNvPr>
@@ -4269,7 +4482,7 @@
           <p:cNvPr id="3" name="Picture Placeholder 2">
             <a:extLst xmlns:a="http://schemas.openxmlformats.org/drawingml/2006/main">
               <a:ext uri="{FF2B5EF4-FFF2-40B4-BE49-F238E27FC236}">
-                <a16:creationId xmlns:a16="http://schemas.microsoft.com/office/drawing/2014/main" id="{4832DB7E-232E-487A-8365-A53702C3B230}"/>
+                <a16:creationId xmlns:a16="http://schemas.microsoft.com/office/drawing/2014/main" id="{B48BFD0A-4DBB-47AE-8937-6CE86F3E4BDE}"/>
               </a:ext>
             </a:extLst>
           </p:cNvPr>
@@ -4338,7 +4551,7 @@
           <p:cNvPr id="4" name="Text Placeholder 3">
             <a:extLst xmlns:a="http://schemas.openxmlformats.org/drawingml/2006/main">
               <a:ext uri="{FF2B5EF4-FFF2-40B4-BE49-F238E27FC236}">
-                <a16:creationId xmlns:a16="http://schemas.microsoft.com/office/drawing/2014/main" id="{780A9F15-71E1-4090-BD6C-C3080CB66B4B}"/>
+                <a16:creationId xmlns:a16="http://schemas.microsoft.com/office/drawing/2014/main" id="{BB13EE4C-71D4-49C8-82FA-6112E59D15AC}"/>
               </a:ext>
             </a:extLst>
           </p:cNvPr>
@@ -4410,7 +4623,7 @@
           <p:cNvPr id="5" name="Date Placeholder 4">
             <a:extLst xmlns:a="http://schemas.openxmlformats.org/drawingml/2006/main">
               <a:ext uri="{FF2B5EF4-FFF2-40B4-BE49-F238E27FC236}">
-                <a16:creationId xmlns:a16="http://schemas.microsoft.com/office/drawing/2014/main" id="{F9C2BA74-F298-469B-8B8D-617439C84743}"/>
+                <a16:creationId xmlns:a16="http://schemas.microsoft.com/office/drawing/2014/main" id="{BF18F6CF-36DD-4ECB-9F65-4695A007E5D5}"/>
               </a:ext>
             </a:extLst>
           </p:cNvPr>
@@ -4438,7 +4651,7 @@
           <p:cNvPr id="6" name="Footer Placeholder 5">
             <a:extLst xmlns:a="http://schemas.openxmlformats.org/drawingml/2006/main">
               <a:ext uri="{FF2B5EF4-FFF2-40B4-BE49-F238E27FC236}">
-                <a16:creationId xmlns:a16="http://schemas.microsoft.com/office/drawing/2014/main" id="{CA9E3A0B-5726-4DAD-B278-40334E4AC729}"/>
+                <a16:creationId xmlns:a16="http://schemas.microsoft.com/office/drawing/2014/main" id="{CD77BAED-C220-4522-ADBD-971572F0BF22}"/>
               </a:ext>
             </a:extLst>
           </p:cNvPr>
@@ -4463,7 +4676,7 @@
           <p:cNvPr id="7" name="Slide Number Placeholder 6">
             <a:extLst xmlns:a="http://schemas.openxmlformats.org/drawingml/2006/main">
               <a:ext uri="{FF2B5EF4-FFF2-40B4-BE49-F238E27FC236}">
-                <a16:creationId xmlns:a16="http://schemas.microsoft.com/office/drawing/2014/main" id="{8C05233D-D564-4048-8B15-787AD470C06D}"/>
+                <a16:creationId xmlns:a16="http://schemas.microsoft.com/office/drawing/2014/main" id="{8FE00A78-5510-43E0-A0F2-C306AE390E5A}"/>
               </a:ext>
             </a:extLst>
           </p:cNvPr>
@@ -4513,7 +4726,7 @@
           <p:cNvPr id="2" name="Title Placeholder 1">
             <a:extLst xmlns:a="http://schemas.openxmlformats.org/drawingml/2006/main">
               <a:ext uri="{FF2B5EF4-FFF2-40B4-BE49-F238E27FC236}">
-                <a16:creationId xmlns:a16="http://schemas.microsoft.com/office/drawing/2014/main" id="{E9323461-E130-42DE-B161-A3E9417010DF}"/>
+                <a16:creationId xmlns:a16="http://schemas.microsoft.com/office/drawing/2014/main" id="{81AF07ED-CBED-4381-931F-F6E5E65985AF}"/>
               </a:ext>
             </a:extLst>
           </p:cNvPr>
@@ -4548,7 +4761,7 @@
           <p:cNvPr id="3" name="Text Placeholder 2">
             <a:extLst xmlns:a="http://schemas.openxmlformats.org/drawingml/2006/main">
               <a:ext uri="{FF2B5EF4-FFF2-40B4-BE49-F238E27FC236}">
-                <a16:creationId xmlns:a16="http://schemas.microsoft.com/office/drawing/2014/main" id="{91F7ED49-6EFA-4537-9FBF-9D4D512721CC}"/>
+                <a16:creationId xmlns:a16="http://schemas.microsoft.com/office/drawing/2014/main" id="{94F3148C-D9B2-4165-A239-C6506FD4340A}"/>
               </a:ext>
             </a:extLst>
           </p:cNvPr>
@@ -4621,7 +4834,7 @@
           <p:cNvPr id="4" name="Date Placeholder 3">
             <a:extLst xmlns:a="http://schemas.openxmlformats.org/drawingml/2006/main">
               <a:ext uri="{FF2B5EF4-FFF2-40B4-BE49-F238E27FC236}">
-                <a16:creationId xmlns:a16="http://schemas.microsoft.com/office/drawing/2014/main" id="{48C4A695-8561-4900-B1BF-5DBE4D098B45}"/>
+                <a16:creationId xmlns:a16="http://schemas.microsoft.com/office/drawing/2014/main" id="{19BCBA23-DCB8-4177-8E99-28EC56C3351C}"/>
               </a:ext>
             </a:extLst>
           </p:cNvPr>
@@ -4668,7 +4881,7 @@
           <p:cNvPr id="5" name="Footer Placeholder 4">
             <a:extLst xmlns:a="http://schemas.openxmlformats.org/drawingml/2006/main">
               <a:ext uri="{FF2B5EF4-FFF2-40B4-BE49-F238E27FC236}">
-                <a16:creationId xmlns:a16="http://schemas.microsoft.com/office/drawing/2014/main" id="{6442C498-9682-445C-8F21-5ADF52596D2E}"/>
+                <a16:creationId xmlns:a16="http://schemas.microsoft.com/office/drawing/2014/main" id="{1509B19D-15A6-41AF-9FF6-087B220BEE5E}"/>
               </a:ext>
             </a:extLst>
           </p:cNvPr>
@@ -4712,7 +4925,7 @@
           <p:cNvPr id="6" name="Slide Number Placeholder 5">
             <a:extLst xmlns:a="http://schemas.openxmlformats.org/drawingml/2006/main">
               <a:ext uri="{FF2B5EF4-FFF2-40B4-BE49-F238E27FC236}">
-                <a16:creationId xmlns:a16="http://schemas.microsoft.com/office/drawing/2014/main" id="{567EEE65-969D-48B4-82AE-2335FD6947D2}"/>
+                <a16:creationId xmlns:a16="http://schemas.microsoft.com/office/drawing/2014/main" id="{F6E6BCCC-80CA-4E5D-B3DF-27D9E0EE06F5}"/>
               </a:ext>
             </a:extLst>
           </p:cNvPr>
@@ -4759,7 +4972,7 @@
           <p:cNvPr id="11" name="Picture 10">
             <a:extLst xmlns:a="http://schemas.openxmlformats.org/drawingml/2006/main">
               <a:ext uri="{FF2B5EF4-FFF2-40B4-BE49-F238E27FC236}">
-                <a16:creationId xmlns:a16="http://schemas.microsoft.com/office/drawing/2014/main" id="{FD204C48-5189-4F43-9451-046C457D50D4}"/>
+                <a16:creationId xmlns:a16="http://schemas.microsoft.com/office/drawing/2014/main" id="{96453AB2-B209-4229-8889-46BB362CCCF0}"/>
               </a:ext>
             </a:extLst>
           </p:cNvPr>
@@ -4769,7 +4982,7 @@
           <p:nvPr/>
         </p:nvPicPr>
         <p:blipFill>
-          <a:blip xmlns:r="http://schemas.openxmlformats.org/officeDocument/2006/relationships" xmlns:a="http://schemas.openxmlformats.org/drawingml/2006/main" r:embed="Rc2dfd52ef1bb482c"/>
+          <a:blip xmlns:r="http://schemas.openxmlformats.org/officeDocument/2006/relationships" xmlns:a="http://schemas.openxmlformats.org/drawingml/2006/main" r:embed="R0da8a5f613ac4b43"/>
           <a:stretch xmlns:a="http://schemas.openxmlformats.org/drawingml/2006/main">
             <a:fillRect l="0" t="0" r="0" b="0"/>
           </a:stretch>
@@ -4788,17 +5001,17 @@
   </p:cSld>
   <p:clrMap bg1="lt1" tx1="dk1" bg2="lt2" tx2="dk2" accent1="accent1" accent2="accent2" accent3="accent3" accent4="accent4" accent5="accent5" accent6="accent6" hlink="hlink" folHlink="folHlink"/>
   <p:sldLayoutIdLst>
-    <p:sldLayoutId xmlns:r="http://schemas.openxmlformats.org/officeDocument/2006/relationships" id="2147483649" r:id="R8c40f08dce2b4165"/>
-    <p:sldLayoutId xmlns:r="http://schemas.openxmlformats.org/officeDocument/2006/relationships" id="2147483650" r:id="R13be633cd98b4b13"/>
-    <p:sldLayoutId xmlns:r="http://schemas.openxmlformats.org/officeDocument/2006/relationships" id="2147483651" r:id="Rf8ef80c1ec4d4803"/>
-    <p:sldLayoutId xmlns:r="http://schemas.openxmlformats.org/officeDocument/2006/relationships" id="2147483652" r:id="R0b0b6ffc7dd54277"/>
-    <p:sldLayoutId xmlns:r="http://schemas.openxmlformats.org/officeDocument/2006/relationships" id="2147483653" r:id="R46e4c4864aeb4d60"/>
-    <p:sldLayoutId xmlns:r="http://schemas.openxmlformats.org/officeDocument/2006/relationships" id="2147483654" r:id="R3172ea02bc274c30"/>
-    <p:sldLayoutId xmlns:r="http://schemas.openxmlformats.org/officeDocument/2006/relationships" id="2147483655" r:id="R3023b8e489d745c7"/>
-    <p:sldLayoutId xmlns:r="http://schemas.openxmlformats.org/officeDocument/2006/relationships" id="2147483656" r:id="Rd848f9e336484bc4"/>
-    <p:sldLayoutId xmlns:r="http://schemas.openxmlformats.org/officeDocument/2006/relationships" id="2147483657" r:id="Rc789f2d5bde94c78"/>
-    <p:sldLayoutId xmlns:r="http://schemas.openxmlformats.org/officeDocument/2006/relationships" id="2147483658" r:id="R3c85d771a6554cf2"/>
-    <p:sldLayoutId xmlns:r="http://schemas.openxmlformats.org/officeDocument/2006/relationships" id="2147483659" r:id="R55d6397936b14030"/>
+    <p:sldLayoutId xmlns:r="http://schemas.openxmlformats.org/officeDocument/2006/relationships" id="2147483649" r:id="R578e844d153c4c39"/>
+    <p:sldLayoutId xmlns:r="http://schemas.openxmlformats.org/officeDocument/2006/relationships" id="2147483650" r:id="R40fb07393db5497d"/>
+    <p:sldLayoutId xmlns:r="http://schemas.openxmlformats.org/officeDocument/2006/relationships" id="2147483651" r:id="R05005d356a7b4397"/>
+    <p:sldLayoutId xmlns:r="http://schemas.openxmlformats.org/officeDocument/2006/relationships" id="2147483652" r:id="Ra64f232dba694ad2"/>
+    <p:sldLayoutId xmlns:r="http://schemas.openxmlformats.org/officeDocument/2006/relationships" id="2147483653" r:id="R486eadea6072411c"/>
+    <p:sldLayoutId xmlns:r="http://schemas.openxmlformats.org/officeDocument/2006/relationships" id="2147483654" r:id="R6aef99220d174982"/>
+    <p:sldLayoutId xmlns:r="http://schemas.openxmlformats.org/officeDocument/2006/relationships" id="2147483655" r:id="Rbe39ae24e862486b"/>
+    <p:sldLayoutId xmlns:r="http://schemas.openxmlformats.org/officeDocument/2006/relationships" id="2147483656" r:id="R22f72216002f4246"/>
+    <p:sldLayoutId xmlns:r="http://schemas.openxmlformats.org/officeDocument/2006/relationships" id="2147483657" r:id="R6c57f0b9e3054cad"/>
+    <p:sldLayoutId xmlns:r="http://schemas.openxmlformats.org/officeDocument/2006/relationships" id="2147483658" r:id="Rfa70d257b74848c3"/>
+    <p:sldLayoutId xmlns:r="http://schemas.openxmlformats.org/officeDocument/2006/relationships" id="2147483659" r:id="R9282cce173d640ba"/>
   </p:sldLayoutIdLst>
   <p:txStyles>
     <p:titleStyle>
@@ -5422,7 +5635,7 @@
           <p:cNvPr id="2" name="Content Placeholder 2">
             <a:extLst xmlns:a="http://schemas.openxmlformats.org/drawingml/2006/main">
               <a:ext uri="{FF2B5EF4-FFF2-40B4-BE49-F238E27FC236}">
-                <a16:creationId xmlns:a16="http://schemas.microsoft.com/office/drawing/2014/main" id="{D8514CD9-F679-4F74-B9A7-3E0301EE9BCF}"/>
+                <a16:creationId xmlns:a16="http://schemas.microsoft.com/office/drawing/2014/main" id="{EB77854E-AE38-4EF5-B06D-8B262A2FE515}"/>
               </a:ext>
             </a:extLst>
           </p:cNvPr>
@@ -5442,7 +5655,7 @@
               <a:buNone/>
             </a:pPr>
             <a:r>
-              <a:t>The saved row appears on return.</a:t>
+              <a:t>The visible list matches saved data.</a:t>
             </a:r>
           </a:p>
           <a:p xmlns:a="http://schemas.openxmlformats.org/drawingml/2006/main">
@@ -5450,7 +5663,7 @@
               <a:buNone/>
             </a:pPr>
             <a:r>
-              <a:t>An edit survives restart.</a:t>
+              <a:t>The page shows an error message.</a:t>
             </a:r>
           </a:p>
         </p:txBody>
@@ -5483,44 +5696,16 @@
           <a:lstStyle xmlns:a="http://schemas.openxmlformats.org/drawingml/2006/main"/>
           <a:p xmlns:a="http://schemas.openxmlformats.org/drawingml/2006/main">
             <a:r>
-              <a:t>Step 4 Check</a:t>
+              <a:t>Step 3: What changed?</a:t>
             </a:r>
             <a:endParaRPr/>
           </a:p>
         </p:txBody>
       </p:sp>
-      <p:pic>
-        <p:nvPicPr>
-          <p:cNvPr id="4" name="">
-            <a:extLst xmlns:a="http://schemas.openxmlformats.org/drawingml/2006/main">
-              <a:ext uri="{FF2B5EF4-FFF2-40B4-BE49-F238E27FC236}">
-                <a16:creationId xmlns:a16="http://schemas.microsoft.com/office/drawing/2014/main" id="{9E0B2281-1474-46BD-B496-69B8E881D75A}"/>
-              </a:ext>
-            </a:extLst>
-          </p:cNvPr>
-          <p:cNvPicPr>
-            <a:picLocks xmlns:a="http://schemas.openxmlformats.org/drawingml/2006/main" noChangeAspect="1"/>
-          </p:cNvPicPr>
-          <p:nvPr/>
-        </p:nvPicPr>
-        <p:blipFill>
-          <a:blip xmlns:r="http://schemas.openxmlformats.org/officeDocument/2006/relationships" xmlns:a="http://schemas.openxmlformats.org/drawingml/2006/main" r:embed="Ra6ef6cc6f6fb4c54"/>
-          <a:stretch xmlns:a="http://schemas.openxmlformats.org/drawingml/2006/main"/>
-        </p:blipFill>
-        <p:spPr>
-          <a:xfrm xmlns:a="http://schemas.openxmlformats.org/drawingml/2006/main">
-            <a:off x="3133823" y="3190875"/>
-            <a:ext cx="5924355" cy="3048000"/>
-          </a:xfrm>
-          <a:prstGeom xmlns:a="http://schemas.openxmlformats.org/drawingml/2006/main" prst="rect">
-            <a:avLst/>
-          </a:prstGeom>
-        </p:spPr>
-      </p:pic>
     </p:spTree>
     <p:extLst>
       <p:ext uri="{BB962C8B-B14F-4D97-AF65-F5344CB8AC3E}">
-        <p14:creationId xmlns:p14="http://schemas.microsoft.com/office/powerpoint/2010/main" val="113428625"/>
+        <p14:creationId xmlns:p14="http://schemas.microsoft.com/office/powerpoint/2010/main" val="24379908"/>
       </p:ext>
     </p:extLst>
   </p:cSld>
@@ -5544,7 +5729,7 @@
           <p:cNvPr id="2" name="Content Placeholder 2">
             <a:extLst xmlns:a="http://schemas.openxmlformats.org/drawingml/2006/main">
               <a:ext uri="{FF2B5EF4-FFF2-40B4-BE49-F238E27FC236}">
-                <a16:creationId xmlns:a16="http://schemas.microsoft.com/office/drawing/2014/main" id="{D8514CD9-F679-4F74-B9A7-3E0301EE9BCF}"/>
+                <a16:creationId xmlns:a16="http://schemas.microsoft.com/office/drawing/2014/main" id="{EB77854E-AE38-4EF5-B06D-8B262A2FE515}"/>
               </a:ext>
             </a:extLst>
           </p:cNvPr>
@@ -5564,7 +5749,7 @@
               <a:buNone/>
             </a:pPr>
             <a:r>
-              <a:t>Test storage with a temporary file.</a:t>
+              <a:t>Load when the BOM page appears.</a:t>
             </a:r>
           </a:p>
           <a:p xmlns:a="http://schemas.openxmlformats.org/drawingml/2006/main">
@@ -5572,7 +5757,7 @@
               <a:buNone/>
             </a:pPr>
             <a:r>
-              <a:t>Test decisions with a fake interaction service.</a:t>
+              <a:t>Use FileSystem.AppDataDirectory for the path.</a:t>
             </a:r>
           </a:p>
         </p:txBody>
@@ -5605,7 +5790,7 @@
           <a:lstStyle xmlns:a="http://schemas.openxmlformats.org/drawingml/2006/main"/>
           <a:p xmlns:a="http://schemas.openxmlformats.org/drawingml/2006/main">
             <a:r>
-              <a:t>Step 5 Automated tests</a:t>
+              <a:t>Step 4: Page lifecycle</a:t>
             </a:r>
             <a:endParaRPr/>
           </a:p>
@@ -5614,7 +5799,7 @@
     </p:spTree>
     <p:extLst>
       <p:ext uri="{BB962C8B-B14F-4D97-AF65-F5344CB8AC3E}">
-        <p14:creationId xmlns:p14="http://schemas.microsoft.com/office/powerpoint/2010/main" val="639258875"/>
+        <p14:creationId xmlns:p14="http://schemas.microsoft.com/office/powerpoint/2010/main" val="151205764"/>
       </p:ext>
     </p:extLst>
   </p:cSld>
@@ -5638,7 +5823,7 @@
           <p:cNvPr id="2" name="Content Placeholder 2">
             <a:extLst xmlns:a="http://schemas.openxmlformats.org/drawingml/2006/main">
               <a:ext uri="{FF2B5EF4-FFF2-40B4-BE49-F238E27FC236}">
-                <a16:creationId xmlns:a16="http://schemas.microsoft.com/office/drawing/2014/main" id="{D8514CD9-F679-4F74-B9A7-3E0301EE9BCF}"/>
+                <a16:creationId xmlns:a16="http://schemas.microsoft.com/office/drawing/2014/main" id="{EB77854E-AE38-4EF5-B06D-8B262A2FE515}"/>
               </a:ext>
             </a:extLst>
           </p:cNvPr>
@@ -5658,7 +5843,7 @@
               <a:buNone/>
             </a:pPr>
             <a:r>
-              <a:t>Save and reload tests pass.</a:t>
+              <a:t>The saved row appears on return.</a:t>
             </a:r>
           </a:p>
           <a:p xmlns:a="http://schemas.openxmlformats.org/drawingml/2006/main">
@@ -5666,7 +5851,7 @@
               <a:buNone/>
             </a:pPr>
             <a:r>
-              <a:t>Cancel and Delete No keep the list.</a:t>
+              <a:t>An edit survives restart.</a:t>
             </a:r>
           </a:p>
         </p:txBody>
@@ -5699,16 +5884,44 @@
           <a:lstStyle xmlns:a="http://schemas.openxmlformats.org/drawingml/2006/main"/>
           <a:p xmlns:a="http://schemas.openxmlformats.org/drawingml/2006/main">
             <a:r>
-              <a:t>Step 5 Check</a:t>
+              <a:t>Step 4: What changed?</a:t>
             </a:r>
             <a:endParaRPr/>
           </a:p>
         </p:txBody>
       </p:sp>
+      <p:pic>
+        <p:nvPicPr>
+          <p:cNvPr id="4" name="">
+            <a:extLst xmlns:a="http://schemas.openxmlformats.org/drawingml/2006/main">
+              <a:ext uri="{FF2B5EF4-FFF2-40B4-BE49-F238E27FC236}">
+                <a16:creationId xmlns:a16="http://schemas.microsoft.com/office/drawing/2014/main" id="{CE392EC7-5D0E-4D48-A901-8477D9FC5FA0}"/>
+              </a:ext>
+            </a:extLst>
+          </p:cNvPr>
+          <p:cNvPicPr>
+            <a:picLocks xmlns:a="http://schemas.openxmlformats.org/drawingml/2006/main" noChangeAspect="1"/>
+          </p:cNvPicPr>
+          <p:nvPr/>
+        </p:nvPicPr>
+        <p:blipFill>
+          <a:blip xmlns:r="http://schemas.openxmlformats.org/officeDocument/2006/relationships" xmlns:a="http://schemas.openxmlformats.org/drawingml/2006/main" r:embed="R6bf73afa825e4655"/>
+          <a:stretch xmlns:a="http://schemas.openxmlformats.org/drawingml/2006/main"/>
+        </p:blipFill>
+        <p:spPr>
+          <a:xfrm xmlns:a="http://schemas.openxmlformats.org/drawingml/2006/main">
+            <a:off x="3133823" y="3190875"/>
+            <a:ext cx="5924355" cy="3048000"/>
+          </a:xfrm>
+          <a:prstGeom xmlns:a="http://schemas.openxmlformats.org/drawingml/2006/main" prst="rect">
+            <a:avLst/>
+          </a:prstGeom>
+        </p:spPr>
+      </p:pic>
     </p:spTree>
     <p:extLst>
       <p:ext uri="{BB962C8B-B14F-4D97-AF65-F5344CB8AC3E}">
-        <p14:creationId xmlns:p14="http://schemas.microsoft.com/office/powerpoint/2010/main" val="1125100999"/>
+        <p14:creationId xmlns:p14="http://schemas.microsoft.com/office/powerpoint/2010/main" val="269389104"/>
       </p:ext>
     </p:extLst>
   </p:cSld>
@@ -5732,7 +5945,7 @@
           <p:cNvPr id="2" name="Content Placeholder 2">
             <a:extLst xmlns:a="http://schemas.openxmlformats.org/drawingml/2006/main">
               <a:ext uri="{FF2B5EF4-FFF2-40B4-BE49-F238E27FC236}">
-                <a16:creationId xmlns:a16="http://schemas.microsoft.com/office/drawing/2014/main" id="{D8514CD9-F679-4F74-B9A7-3E0301EE9BCF}"/>
+                <a16:creationId xmlns:a16="http://schemas.microsoft.com/office/drawing/2014/main" id="{EB77854E-AE38-4EF5-B06D-8B262A2FE515}"/>
               </a:ext>
             </a:extLst>
           </p:cNvPr>
@@ -5752,7 +5965,7 @@
               <a:buNone/>
             </a:pPr>
             <a:r>
-              <a:t>Show the completed app workflow.</a:t>
+              <a:t>Test storage with a temporary file.</a:t>
             </a:r>
           </a:p>
           <a:p xmlns:a="http://schemas.openxmlformats.org/drawingml/2006/main">
@@ -5760,15 +5973,7 @@
               <a:buNone/>
             </a:pPr>
             <a:r>
-              <a:t>Explain which responsibility changed.</a:t>
-            </a:r>
-          </a:p>
-          <a:p xmlns:a="http://schemas.openxmlformats.org/drawingml/2006/main">
-            <a:pPr lvl="0">
-              <a:buNone/>
-            </a:pPr>
-            <a:r>
-              <a:t>Check the result before the next module.</a:t>
+              <a:t>Test decisions with a fake interaction service.</a:t>
             </a:r>
           </a:p>
         </p:txBody>
@@ -5801,7 +6006,7 @@
           <a:lstStyle xmlns:a="http://schemas.openxmlformats.org/drawingml/2006/main"/>
           <a:p xmlns:a="http://schemas.openxmlformats.org/drawingml/2006/main">
             <a:r>
-              <a:t>Module review</a:t>
+              <a:t>Step 5: Automated tests</a:t>
             </a:r>
             <a:endParaRPr/>
           </a:p>
@@ -5810,7 +6015,305 @@
     </p:spTree>
     <p:extLst>
       <p:ext uri="{BB962C8B-B14F-4D97-AF65-F5344CB8AC3E}">
-        <p14:creationId xmlns:p14="http://schemas.microsoft.com/office/powerpoint/2010/main" val="1669253644"/>
+        <p14:creationId xmlns:p14="http://schemas.microsoft.com/office/powerpoint/2010/main" val="1425982875"/>
+      </p:ext>
+    </p:extLst>
+  </p:cSld>
+</p:sld>
+</file>
+
+<file path=ppt/slides/slide14.xml><?xml version="1.0" encoding="utf-8"?>
+<p:sld xmlns:p="http://schemas.openxmlformats.org/presentationml/2006/main">
+  <p:cSld>
+    <p:spTree>
+      <p:nvGrpSpPr>
+        <p:cNvPr id="1" name=""/>
+        <p:cNvGrpSpPr/>
+        <p:nvPr/>
+      </p:nvGrpSpPr>
+      <p:grpSpPr>
+        <a:xfrm xmlns:a="http://schemas.openxmlformats.org/drawingml/2006/main"/>
+      </p:grpSpPr>
+      <p:sp>
+        <p:nvSpPr>
+          <p:cNvPr id="2" name="Content Placeholder 2">
+            <a:extLst xmlns:a="http://schemas.openxmlformats.org/drawingml/2006/main">
+              <a:ext uri="{FF2B5EF4-FFF2-40B4-BE49-F238E27FC236}">
+                <a16:creationId xmlns:a16="http://schemas.microsoft.com/office/drawing/2014/main" id="{EB77854E-AE38-4EF5-B06D-8B262A2FE515}"/>
+              </a:ext>
+            </a:extLst>
+          </p:cNvPr>
+          <p:cNvSpPr>
+            <a:spLocks xmlns:a="http://schemas.openxmlformats.org/drawingml/2006/main" noGrp="1"/>
+          </p:cNvSpPr>
+          <p:nvPr>
+            <p:ph idx="1"/>
+          </p:nvPr>
+        </p:nvSpPr>
+        <p:spPr/>
+        <p:txBody>
+          <a:bodyPr xmlns:a="http://schemas.openxmlformats.org/drawingml/2006/main"/>
+          <a:lstStyle xmlns:a="http://schemas.openxmlformats.org/drawingml/2006/main"/>
+          <a:p xmlns:a="http://schemas.openxmlformats.org/drawingml/2006/main">
+            <a:pPr lvl="0">
+              <a:buNone/>
+            </a:pPr>
+            <a:r>
+              <a:t>Save and reload tests pass.</a:t>
+            </a:r>
+          </a:p>
+          <a:p xmlns:a="http://schemas.openxmlformats.org/drawingml/2006/main">
+            <a:pPr lvl="0">
+              <a:buNone/>
+            </a:pPr>
+            <a:r>
+              <a:t>Cancel and Delete No keep the list.</a:t>
+            </a:r>
+          </a:p>
+        </p:txBody>
+      </p:sp>
+      <p:sp>
+        <p:nvSpPr>
+          <p:cNvPr id="3" name="Title Placeholder 1">
+            <a:extLst xmlns:a="http://schemas.openxmlformats.org/drawingml/2006/main">
+              <a:ext uri="{FF2B5EF4-FFF2-40B4-BE49-F238E27FC236}">
+                <a16:creationId xmlns:a16="http://schemas.microsoft.com/office/drawing/2014/main" id="{2DF4F548-EDEF-186D-6633-AF1ABC814BC1}"/>
+              </a:ext>
+            </a:extLst>
+          </p:cNvPr>
+          <p:cNvSpPr>
+            <a:spLocks xmlns:a="http://schemas.openxmlformats.org/drawingml/2006/main" noGrp="1"/>
+          </p:cNvSpPr>
+          <p:nvPr>
+            <p:ph type="title" idx="0"/>
+          </p:nvPr>
+        </p:nvSpPr>
+        <p:spPr>
+          <a:prstGeom xmlns:a="http://schemas.openxmlformats.org/drawingml/2006/main" prst="rect">
+            <a:avLst/>
+          </a:prstGeom>
+        </p:spPr>
+        <p:txBody>
+          <a:bodyPr xmlns:a="http://schemas.openxmlformats.org/drawingml/2006/main" vert="horz" lIns="91440" tIns="45720" rIns="91440" bIns="45720" anchor="ctr">
+            <a:normAutofit fontScale="100000"/>
+          </a:bodyPr>
+          <a:lstStyle xmlns:a="http://schemas.openxmlformats.org/drawingml/2006/main"/>
+          <a:p xmlns:a="http://schemas.openxmlformats.org/drawingml/2006/main">
+            <a:r>
+              <a:t>Step 5: What changed?</a:t>
+            </a:r>
+            <a:endParaRPr/>
+          </a:p>
+        </p:txBody>
+      </p:sp>
+    </p:spTree>
+    <p:extLst>
+      <p:ext uri="{BB962C8B-B14F-4D97-AF65-F5344CB8AC3E}">
+        <p14:creationId xmlns:p14="http://schemas.microsoft.com/office/powerpoint/2010/main" val="799886550"/>
+      </p:ext>
+    </p:extLst>
+  </p:cSld>
+</p:sld>
+</file>
+
+<file path=ppt/slides/slide15.xml><?xml version="1.0" encoding="utf-8"?>
+<p:sld xmlns:p="http://schemas.openxmlformats.org/presentationml/2006/main">
+  <p:cSld>
+    <p:spTree>
+      <p:nvGrpSpPr>
+        <p:cNvPr id="1" name=""/>
+        <p:cNvGrpSpPr/>
+        <p:nvPr/>
+      </p:nvGrpSpPr>
+      <p:grpSpPr>
+        <a:xfrm xmlns:a="http://schemas.openxmlformats.org/drawingml/2006/main"/>
+      </p:grpSpPr>
+      <p:sp>
+        <p:nvSpPr>
+          <p:cNvPr id="2" name="Content Placeholder 2">
+            <a:extLst xmlns:a="http://schemas.openxmlformats.org/drawingml/2006/main">
+              <a:ext uri="{FF2B5EF4-FFF2-40B4-BE49-F238E27FC236}">
+                <a16:creationId xmlns:a16="http://schemas.microsoft.com/office/drawing/2014/main" id="{EB77854E-AE38-4EF5-B06D-8B262A2FE515}"/>
+              </a:ext>
+            </a:extLst>
+          </p:cNvPr>
+          <p:cNvSpPr>
+            <a:spLocks xmlns:a="http://schemas.openxmlformats.org/drawingml/2006/main" noGrp="1"/>
+          </p:cNvSpPr>
+          <p:nvPr>
+            <p:ph idx="1"/>
+          </p:nvPr>
+        </p:nvSpPr>
+        <p:spPr/>
+        <p:txBody>
+          <a:bodyPr xmlns:a="http://schemas.openxmlformats.org/drawingml/2006/main"/>
+          <a:lstStyle xmlns:a="http://schemas.openxmlformats.org/drawingml/2006/main"/>
+          <a:p xmlns:a="http://schemas.openxmlformats.org/drawingml/2006/main">
+            <a:pPr lvl="0">
+              <a:buNone/>
+            </a:pPr>
+            <a:r>
+              <a:t>I can trace a changed item to the JSON file.</a:t>
+            </a:r>
+          </a:p>
+          <a:p xmlns:a="http://schemas.openxmlformats.org/drawingml/2006/main">
+            <a:pPr lvl="0">
+              <a:buNone/>
+            </a:pPr>
+            <a:r>
+              <a:t>I can explain why callers await the service.</a:t>
+            </a:r>
+          </a:p>
+          <a:p xmlns:a="http://schemas.openxmlformats.org/drawingml/2006/main">
+            <a:pPr lvl="0">
+              <a:buNone/>
+            </a:pPr>
+            <a:r>
+              <a:t>I can describe what a failed save does to the list.</a:t>
+            </a:r>
+          </a:p>
+        </p:txBody>
+      </p:sp>
+      <p:sp>
+        <p:nvSpPr>
+          <p:cNvPr id="3" name="Title Placeholder 1">
+            <a:extLst xmlns:a="http://schemas.openxmlformats.org/drawingml/2006/main">
+              <a:ext uri="{FF2B5EF4-FFF2-40B4-BE49-F238E27FC236}">
+                <a16:creationId xmlns:a16="http://schemas.microsoft.com/office/drawing/2014/main" id="{2DF4F548-EDEF-186D-6633-AF1ABC814BC1}"/>
+              </a:ext>
+            </a:extLst>
+          </p:cNvPr>
+          <p:cNvSpPr>
+            <a:spLocks xmlns:a="http://schemas.openxmlformats.org/drawingml/2006/main" noGrp="1"/>
+          </p:cNvSpPr>
+          <p:nvPr>
+            <p:ph type="title" idx="0"/>
+          </p:nvPr>
+        </p:nvSpPr>
+        <p:spPr>
+          <a:prstGeom xmlns:a="http://schemas.openxmlformats.org/drawingml/2006/main" prst="rect">
+            <a:avLst/>
+          </a:prstGeom>
+        </p:spPr>
+        <p:txBody>
+          <a:bodyPr xmlns:a="http://schemas.openxmlformats.org/drawingml/2006/main" vert="horz" lIns="91440" tIns="45720" rIns="91440" bIns="45720" anchor="ctr">
+            <a:normAutofit fontScale="100000"/>
+          </a:bodyPr>
+          <a:lstStyle xmlns:a="http://schemas.openxmlformats.org/drawingml/2006/main"/>
+          <a:p xmlns:a="http://schemas.openxmlformats.org/drawingml/2006/main">
+            <a:r>
+              <a:t>What you can now explain</a:t>
+            </a:r>
+            <a:endParaRPr/>
+          </a:p>
+        </p:txBody>
+      </p:sp>
+    </p:spTree>
+    <p:extLst>
+      <p:ext uri="{BB962C8B-B14F-4D97-AF65-F5344CB8AC3E}">
+        <p14:creationId xmlns:p14="http://schemas.microsoft.com/office/powerpoint/2010/main" val="1928712978"/>
+      </p:ext>
+    </p:extLst>
+  </p:cSld>
+</p:sld>
+</file>
+
+<file path=ppt/slides/slide16.xml><?xml version="1.0" encoding="utf-8"?>
+<p:sld xmlns:p="http://schemas.openxmlformats.org/presentationml/2006/main">
+  <p:cSld>
+    <p:spTree>
+      <p:nvGrpSpPr>
+        <p:cNvPr id="1" name=""/>
+        <p:cNvGrpSpPr/>
+        <p:nvPr/>
+      </p:nvGrpSpPr>
+      <p:grpSpPr>
+        <a:xfrm xmlns:a="http://schemas.openxmlformats.org/drawingml/2006/main"/>
+      </p:grpSpPr>
+      <p:sp>
+        <p:nvSpPr>
+          <p:cNvPr id="2" name="Content Placeholder 2">
+            <a:extLst xmlns:a="http://schemas.openxmlformats.org/drawingml/2006/main">
+              <a:ext uri="{FF2B5EF4-FFF2-40B4-BE49-F238E27FC236}">
+                <a16:creationId xmlns:a16="http://schemas.microsoft.com/office/drawing/2014/main" id="{EB77854E-AE38-4EF5-B06D-8B262A2FE515}"/>
+              </a:ext>
+            </a:extLst>
+          </p:cNvPr>
+          <p:cNvSpPr>
+            <a:spLocks xmlns:a="http://schemas.openxmlformats.org/drawingml/2006/main" noGrp="1"/>
+          </p:cNvSpPr>
+          <p:nvPr>
+            <p:ph idx="1"/>
+          </p:nvPr>
+        </p:nvSpPr>
+        <p:spPr/>
+        <p:txBody>
+          <a:bodyPr xmlns:a="http://schemas.openxmlformats.org/drawingml/2006/main"/>
+          <a:lstStyle xmlns:a="http://schemas.openxmlformats.org/drawingml/2006/main"/>
+          <a:p xmlns:a="http://schemas.openxmlformats.org/drawingml/2006/main">
+            <a:pPr lvl="0">
+              <a:buNone/>
+            </a:pPr>
+            <a:r>
+              <a:t>App data and file system</a:t>
+            </a:r>
+          </a:p>
+          <a:p xmlns:a="http://schemas.openxmlformats.org/drawingml/2006/main">
+            <a:pPr lvl="0">
+              <a:buNone/>
+            </a:pPr>
+            <a:r>
+              <a:t>Search Microsoft Learn for this topic.</a:t>
+            </a:r>
+          </a:p>
+          <a:p xmlns:a="http://schemas.openxmlformats.org/drawingml/2006/main">
+            <a:pPr lvl="0">
+              <a:buNone/>
+            </a:pPr>
+            <a:r>
+              <a:t>Try one example in a small test page.</a:t>
+            </a:r>
+          </a:p>
+        </p:txBody>
+      </p:sp>
+      <p:sp>
+        <p:nvSpPr>
+          <p:cNvPr id="3" name="Title Placeholder 1">
+            <a:extLst xmlns:a="http://schemas.openxmlformats.org/drawingml/2006/main">
+              <a:ext uri="{FF2B5EF4-FFF2-40B4-BE49-F238E27FC236}">
+                <a16:creationId xmlns:a16="http://schemas.microsoft.com/office/drawing/2014/main" id="{2DF4F548-EDEF-186D-6633-AF1ABC814BC1}"/>
+              </a:ext>
+            </a:extLst>
+          </p:cNvPr>
+          <p:cNvSpPr>
+            <a:spLocks xmlns:a="http://schemas.openxmlformats.org/drawingml/2006/main" noGrp="1"/>
+          </p:cNvSpPr>
+          <p:nvPr>
+            <p:ph type="title" idx="0"/>
+          </p:nvPr>
+        </p:nvSpPr>
+        <p:spPr>
+          <a:prstGeom xmlns:a="http://schemas.openxmlformats.org/drawingml/2006/main" prst="rect">
+            <a:avLst/>
+          </a:prstGeom>
+        </p:spPr>
+        <p:txBody>
+          <a:bodyPr xmlns:a="http://schemas.openxmlformats.org/drawingml/2006/main" vert="horz" lIns="91440" tIns="45720" rIns="91440" bIns="45720" anchor="ctr">
+            <a:normAutofit fontScale="100000"/>
+          </a:bodyPr>
+          <a:lstStyle xmlns:a="http://schemas.openxmlformats.org/drawingml/2006/main"/>
+          <a:p xmlns:a="http://schemas.openxmlformats.org/drawingml/2006/main">
+            <a:r>
+              <a:t>Read more in MAUI documentation</a:t>
+            </a:r>
+            <a:endParaRPr/>
+          </a:p>
+        </p:txBody>
+      </p:sp>
+    </p:spTree>
+    <p:extLst>
+      <p:ext uri="{BB962C8B-B14F-4D97-AF65-F5344CB8AC3E}">
+        <p14:creationId xmlns:p14="http://schemas.microsoft.com/office/powerpoint/2010/main" val="1991916190"/>
       </p:ext>
     </p:extLst>
   </p:cSld>
@@ -5834,7 +6337,7 @@
           <p:cNvPr id="2" name="Content Placeholder 2">
             <a:extLst xmlns:a="http://schemas.openxmlformats.org/drawingml/2006/main">
               <a:ext uri="{FF2B5EF4-FFF2-40B4-BE49-F238E27FC236}">
-                <a16:creationId xmlns:a16="http://schemas.microsoft.com/office/drawing/2014/main" id="{D8514CD9-F679-4F74-B9A7-3E0301EE9BCF}"/>
+                <a16:creationId xmlns:a16="http://schemas.microsoft.com/office/drawing/2014/main" id="{EB77854E-AE38-4EF5-B06D-8B262A2FE515}"/>
               </a:ext>
             </a:extLst>
           </p:cNvPr>
@@ -5903,7 +6406,7 @@
           <a:lstStyle xmlns:a="http://schemas.openxmlformats.org/drawingml/2006/main"/>
           <a:p xmlns:a="http://schemas.openxmlformats.org/drawingml/2006/main">
             <a:r>
-              <a:t>Exercise overview</a:t>
+              <a:t>What you will build</a:t>
             </a:r>
             <a:endParaRPr/>
           </a:p>
@@ -5912,7 +6415,7 @@
     </p:spTree>
     <p:extLst>
       <p:ext uri="{BB962C8B-B14F-4D97-AF65-F5344CB8AC3E}">
-        <p14:creationId xmlns:p14="http://schemas.microsoft.com/office/powerpoint/2010/main" val="376810290"/>
+        <p14:creationId xmlns:p14="http://schemas.microsoft.com/office/powerpoint/2010/main" val="492834524"/>
       </p:ext>
     </p:extLst>
   </p:cSld>
@@ -5936,7 +6439,7 @@
           <p:cNvPr id="2" name="Content Placeholder 2">
             <a:extLst xmlns:a="http://schemas.openxmlformats.org/drawingml/2006/main">
               <a:ext uri="{FF2B5EF4-FFF2-40B4-BE49-F238E27FC236}">
-                <a16:creationId xmlns:a16="http://schemas.microsoft.com/office/drawing/2014/main" id="{D8514CD9-F679-4F74-B9A7-3E0301EE9BCF}"/>
+                <a16:creationId xmlns:a16="http://schemas.microsoft.com/office/drawing/2014/main" id="{EB77854E-AE38-4EF5-B06D-8B262A2FE515}"/>
               </a:ext>
             </a:extLst>
           </p:cNvPr>
@@ -5956,7 +6459,7 @@
               <a:buNone/>
             </a:pPr>
             <a:r>
-              <a:t>File work can take time.</a:t>
+              <a:t>An in-memory collection ends when the app closes.</a:t>
             </a:r>
           </a:p>
           <a:p xmlns:a="http://schemas.openxmlformats.org/drawingml/2006/main">
@@ -5964,7 +6467,15 @@
               <a:buNone/>
             </a:pPr>
             <a:r>
-              <a:t>Task-returning methods keep the UI responsive.</a:t>
+              <a:t>A JSON file keeps item values between runs.</a:t>
+            </a:r>
+          </a:p>
+          <a:p xmlns:a="http://schemas.openxmlformats.org/drawingml/2006/main">
+            <a:pPr lvl="0">
+              <a:buNone/>
+            </a:pPr>
+            <a:r>
+              <a:t>Async file methods let the UI await the operation.</a:t>
             </a:r>
           </a:p>
         </p:txBody>
@@ -5992,21 +6503,49 @@
         </p:spPr>
         <p:txBody>
           <a:bodyPr xmlns:a="http://schemas.openxmlformats.org/drawingml/2006/main" vert="horz" lIns="91440" tIns="45720" rIns="91440" bIns="45720" anchor="ctr">
-            <a:normAutofit fontScale="100000"/>
+            <a:normAutofit fontScale="88008"/>
           </a:bodyPr>
           <a:lstStyle xmlns:a="http://schemas.openxmlformats.org/drawingml/2006/main"/>
           <a:p xmlns:a="http://schemas.openxmlformats.org/drawingml/2006/main">
             <a:r>
-              <a:t>Step 1 Async storage</a:t>
+              <a:t>Storage crosses the app process boundary</a:t>
             </a:r>
             <a:endParaRPr/>
           </a:p>
         </p:txBody>
       </p:sp>
+      <p:pic>
+        <p:nvPicPr>
+          <p:cNvPr id="4" name="">
+            <a:extLst xmlns:a="http://schemas.openxmlformats.org/drawingml/2006/main">
+              <a:ext uri="{FF2B5EF4-FFF2-40B4-BE49-F238E27FC236}">
+                <a16:creationId xmlns:a16="http://schemas.microsoft.com/office/drawing/2014/main" id="{60FCA125-78F1-4A1A-A17F-5ED2AF2CBBDB}"/>
+              </a:ext>
+            </a:extLst>
+          </p:cNvPr>
+          <p:cNvPicPr>
+            <a:picLocks xmlns:a="http://schemas.openxmlformats.org/drawingml/2006/main" noChangeAspect="1"/>
+          </p:cNvPicPr>
+          <p:nvPr/>
+        </p:nvPicPr>
+        <p:blipFill>
+          <a:blip xmlns:r="http://schemas.openxmlformats.org/officeDocument/2006/relationships" xmlns:a="http://schemas.openxmlformats.org/drawingml/2006/main" r:embed="R95353ab4eda94750"/>
+          <a:stretch xmlns:a="http://schemas.openxmlformats.org/drawingml/2006/main"/>
+        </p:blipFill>
+        <p:spPr>
+          <a:xfrm xmlns:a="http://schemas.openxmlformats.org/drawingml/2006/main">
+            <a:off x="2667000" y="3800475"/>
+            <a:ext cx="6858000" cy="1828800"/>
+          </a:xfrm>
+          <a:prstGeom xmlns:a="http://schemas.openxmlformats.org/drawingml/2006/main" prst="rect">
+            <a:avLst/>
+          </a:prstGeom>
+        </p:spPr>
+      </p:pic>
     </p:spTree>
     <p:extLst>
       <p:ext uri="{BB962C8B-B14F-4D97-AF65-F5344CB8AC3E}">
-        <p14:creationId xmlns:p14="http://schemas.microsoft.com/office/powerpoint/2010/main" val="78678303"/>
+        <p14:creationId xmlns:p14="http://schemas.microsoft.com/office/powerpoint/2010/main" val="9118960"/>
       </p:ext>
     </p:extLst>
   </p:cSld>
@@ -6030,7 +6569,7 @@
           <p:cNvPr id="2" name="Content Placeholder 2">
             <a:extLst xmlns:a="http://schemas.openxmlformats.org/drawingml/2006/main">
               <a:ext uri="{FF2B5EF4-FFF2-40B4-BE49-F238E27FC236}">
-                <a16:creationId xmlns:a16="http://schemas.microsoft.com/office/drawing/2014/main" id="{D8514CD9-F679-4F74-B9A7-3E0301EE9BCF}"/>
+                <a16:creationId xmlns:a16="http://schemas.microsoft.com/office/drawing/2014/main" id="{EB77854E-AE38-4EF5-B06D-8B262A2FE515}"/>
               </a:ext>
             </a:extLst>
           </p:cNvPr>
@@ -6050,7 +6589,7 @@
               <a:buNone/>
             </a:pPr>
             <a:r>
-              <a:t>All callers await the service.</a:t>
+              <a:t>The service writes in AppDataDirectory.</a:t>
             </a:r>
           </a:p>
           <a:p xmlns:a="http://schemas.openxmlformats.org/drawingml/2006/main">
@@ -6058,7 +6597,15 @@
               <a:buNone/>
             </a:pPr>
             <a:r>
-              <a:t>The app still builds.</a:t>
+              <a:t>Load restores items when the BOM page appears.</a:t>
+            </a:r>
+          </a:p>
+          <a:p xmlns:a="http://schemas.openxmlformats.org/drawingml/2006/main">
+            <a:pPr lvl="0">
+              <a:buNone/>
+            </a:pPr>
+            <a:r>
+              <a:t>A failed save must leave the visible list consistent.</a:t>
             </a:r>
           </a:p>
         </p:txBody>
@@ -6091,44 +6638,16 @@
           <a:lstStyle xmlns:a="http://schemas.openxmlformats.org/drawingml/2006/main"/>
           <a:p xmlns:a="http://schemas.openxmlformats.org/drawingml/2006/main">
             <a:r>
-              <a:t>Step 1 Check</a:t>
+              <a:t>From C# to the screen</a:t>
             </a:r>
             <a:endParaRPr/>
           </a:p>
         </p:txBody>
       </p:sp>
-      <p:pic>
-        <p:nvPicPr>
-          <p:cNvPr id="4" name="">
-            <a:extLst xmlns:a="http://schemas.openxmlformats.org/drawingml/2006/main">
-              <a:ext uri="{FF2B5EF4-FFF2-40B4-BE49-F238E27FC236}">
-                <a16:creationId xmlns:a16="http://schemas.microsoft.com/office/drawing/2014/main" id="{5CE53EC5-2D50-4BF9-93C0-09B760C9CB2F}"/>
-              </a:ext>
-            </a:extLst>
-          </p:cNvPr>
-          <p:cNvPicPr>
-            <a:picLocks xmlns:a="http://schemas.openxmlformats.org/drawingml/2006/main" noChangeAspect="1"/>
-          </p:cNvPicPr>
-          <p:nvPr/>
-        </p:nvPicPr>
-        <p:blipFill>
-          <a:blip xmlns:r="http://schemas.openxmlformats.org/officeDocument/2006/relationships" xmlns:a="http://schemas.openxmlformats.org/drawingml/2006/main" r:embed="R5026bc8fdab54450"/>
-          <a:stretch xmlns:a="http://schemas.openxmlformats.org/drawingml/2006/main"/>
-        </p:blipFill>
-        <p:spPr>
-          <a:xfrm xmlns:a="http://schemas.openxmlformats.org/drawingml/2006/main">
-            <a:off x="2667000" y="3800475"/>
-            <a:ext cx="6858000" cy="1828800"/>
-          </a:xfrm>
-          <a:prstGeom xmlns:a="http://schemas.openxmlformats.org/drawingml/2006/main" prst="rect">
-            <a:avLst/>
-          </a:prstGeom>
-        </p:spPr>
-      </p:pic>
     </p:spTree>
     <p:extLst>
       <p:ext uri="{BB962C8B-B14F-4D97-AF65-F5344CB8AC3E}">
-        <p14:creationId xmlns:p14="http://schemas.microsoft.com/office/powerpoint/2010/main" val="146023476"/>
+        <p14:creationId xmlns:p14="http://schemas.microsoft.com/office/powerpoint/2010/main" val="569942391"/>
       </p:ext>
     </p:extLst>
   </p:cSld>
@@ -6152,7 +6671,7 @@
           <p:cNvPr id="2" name="Content Placeholder 2">
             <a:extLst xmlns:a="http://schemas.openxmlformats.org/drawingml/2006/main">
               <a:ext uri="{FF2B5EF4-FFF2-40B4-BE49-F238E27FC236}">
-                <a16:creationId xmlns:a16="http://schemas.microsoft.com/office/drawing/2014/main" id="{D8514CD9-F679-4F74-B9A7-3E0301EE9BCF}"/>
+                <a16:creationId xmlns:a16="http://schemas.microsoft.com/office/drawing/2014/main" id="{EB77854E-AE38-4EF5-B06D-8B262A2FE515}"/>
               </a:ext>
             </a:extLst>
           </p:cNvPr>
@@ -6172,7 +6691,7 @@
               <a:buNone/>
             </a:pPr>
             <a:r>
-              <a:t>JsonBomService writes the item list.</a:t>
+              <a:t>File work can take time.</a:t>
             </a:r>
           </a:p>
           <a:p xmlns:a="http://schemas.openxmlformats.org/drawingml/2006/main">
@@ -6180,7 +6699,7 @@
               <a:buNone/>
             </a:pPr>
             <a:r>
-              <a:t>A new service instance loads it.</a:t>
+              <a:t>Task-returning methods keep the UI responsive.</a:t>
             </a:r>
           </a:p>
         </p:txBody>
@@ -6213,7 +6732,7 @@
           <a:lstStyle xmlns:a="http://schemas.openxmlformats.org/drawingml/2006/main"/>
           <a:p xmlns:a="http://schemas.openxmlformats.org/drawingml/2006/main">
             <a:r>
-              <a:t>Step 2 JSON service</a:t>
+              <a:t>Step 1: Async storage</a:t>
             </a:r>
             <a:endParaRPr/>
           </a:p>
@@ -6222,7 +6741,7 @@
     </p:spTree>
     <p:extLst>
       <p:ext uri="{BB962C8B-B14F-4D97-AF65-F5344CB8AC3E}">
-        <p14:creationId xmlns:p14="http://schemas.microsoft.com/office/powerpoint/2010/main" val="732492111"/>
+        <p14:creationId xmlns:p14="http://schemas.microsoft.com/office/powerpoint/2010/main" val="688028176"/>
       </p:ext>
     </p:extLst>
   </p:cSld>
@@ -6246,7 +6765,7 @@
           <p:cNvPr id="2" name="Content Placeholder 2">
             <a:extLst xmlns:a="http://schemas.openxmlformats.org/drawingml/2006/main">
               <a:ext uri="{FF2B5EF4-FFF2-40B4-BE49-F238E27FC236}">
-                <a16:creationId xmlns:a16="http://schemas.microsoft.com/office/drawing/2014/main" id="{D8514CD9-F679-4F74-B9A7-3E0301EE9BCF}"/>
+                <a16:creationId xmlns:a16="http://schemas.microsoft.com/office/drawing/2014/main" id="{EB77854E-AE38-4EF5-B06D-8B262A2FE515}"/>
               </a:ext>
             </a:extLst>
           </p:cNvPr>
@@ -6266,7 +6785,7 @@
               <a:buNone/>
             </a:pPr>
             <a:r>
-              <a:t>A service instance reloads saved items.</a:t>
+              <a:t>All callers await the service.</a:t>
             </a:r>
           </a:p>
           <a:p xmlns:a="http://schemas.openxmlformats.org/drawingml/2006/main">
@@ -6274,7 +6793,7 @@
               <a:buNone/>
             </a:pPr>
             <a:r>
-              <a:t>The JSON data has the item values.</a:t>
+              <a:t>The app still builds.</a:t>
             </a:r>
           </a:p>
         </p:txBody>
@@ -6307,7 +6826,7 @@
           <a:lstStyle xmlns:a="http://schemas.openxmlformats.org/drawingml/2006/main"/>
           <a:p xmlns:a="http://schemas.openxmlformats.org/drawingml/2006/main">
             <a:r>
-              <a:t>Step 2 Check</a:t>
+              <a:t>Step 1: What changed?</a:t>
             </a:r>
             <a:endParaRPr/>
           </a:p>
@@ -6316,7 +6835,7 @@
     </p:spTree>
     <p:extLst>
       <p:ext uri="{BB962C8B-B14F-4D97-AF65-F5344CB8AC3E}">
-        <p14:creationId xmlns:p14="http://schemas.microsoft.com/office/powerpoint/2010/main" val="554201091"/>
+        <p14:creationId xmlns:p14="http://schemas.microsoft.com/office/powerpoint/2010/main" val="530365742"/>
       </p:ext>
     </p:extLst>
   </p:cSld>
@@ -6340,7 +6859,7 @@
           <p:cNvPr id="2" name="Content Placeholder 2">
             <a:extLst xmlns:a="http://schemas.openxmlformats.org/drawingml/2006/main">
               <a:ext uri="{FF2B5EF4-FFF2-40B4-BE49-F238E27FC236}">
-                <a16:creationId xmlns:a16="http://schemas.microsoft.com/office/drawing/2014/main" id="{D8514CD9-F679-4F74-B9A7-3E0301EE9BCF}"/>
+                <a16:creationId xmlns:a16="http://schemas.microsoft.com/office/drawing/2014/main" id="{EB77854E-AE38-4EF5-B06D-8B262A2FE515}"/>
               </a:ext>
             </a:extLst>
           </p:cNvPr>
@@ -6360,7 +6879,7 @@
               <a:buNone/>
             </a:pPr>
             <a:r>
-              <a:t>A failed write must not leave a false row.</a:t>
+              <a:t>JsonBomService writes the item list.</a:t>
             </a:r>
           </a:p>
           <a:p xmlns:a="http://schemas.openxmlformats.org/drawingml/2006/main">
@@ -6368,7 +6887,7 @@
               <a:buNone/>
             </a:pPr>
             <a:r>
-              <a:t>Restore the collection after an error.</a:t>
+              <a:t>A new service instance loads it.</a:t>
             </a:r>
           </a:p>
         </p:txBody>
@@ -6401,7 +6920,7 @@
           <a:lstStyle xmlns:a="http://schemas.openxmlformats.org/drawingml/2006/main"/>
           <a:p xmlns:a="http://schemas.openxmlformats.org/drawingml/2006/main">
             <a:r>
-              <a:t>Step 3 Failed save</a:t>
+              <a:t>Step 2: JSON service</a:t>
             </a:r>
             <a:endParaRPr/>
           </a:p>
@@ -6410,7 +6929,7 @@
     </p:spTree>
     <p:extLst>
       <p:ext uri="{BB962C8B-B14F-4D97-AF65-F5344CB8AC3E}">
-        <p14:creationId xmlns:p14="http://schemas.microsoft.com/office/powerpoint/2010/main" val="579436624"/>
+        <p14:creationId xmlns:p14="http://schemas.microsoft.com/office/powerpoint/2010/main" val="127654753"/>
       </p:ext>
     </p:extLst>
   </p:cSld>
@@ -6434,7 +6953,7 @@
           <p:cNvPr id="2" name="Content Placeholder 2">
             <a:extLst xmlns:a="http://schemas.openxmlformats.org/drawingml/2006/main">
               <a:ext uri="{FF2B5EF4-FFF2-40B4-BE49-F238E27FC236}">
-                <a16:creationId xmlns:a16="http://schemas.microsoft.com/office/drawing/2014/main" id="{D8514CD9-F679-4F74-B9A7-3E0301EE9BCF}"/>
+                <a16:creationId xmlns:a16="http://schemas.microsoft.com/office/drawing/2014/main" id="{EB77854E-AE38-4EF5-B06D-8B262A2FE515}"/>
               </a:ext>
             </a:extLst>
           </p:cNvPr>
@@ -6454,7 +6973,7 @@
               <a:buNone/>
             </a:pPr>
             <a:r>
-              <a:t>The visible list matches saved data.</a:t>
+              <a:t>A service instance reloads saved items.</a:t>
             </a:r>
           </a:p>
           <a:p xmlns:a="http://schemas.openxmlformats.org/drawingml/2006/main">
@@ -6462,7 +6981,7 @@
               <a:buNone/>
             </a:pPr>
             <a:r>
-              <a:t>The page shows an error message.</a:t>
+              <a:t>The JSON data has the item values.</a:t>
             </a:r>
           </a:p>
         </p:txBody>
@@ -6495,7 +7014,7 @@
           <a:lstStyle xmlns:a="http://schemas.openxmlformats.org/drawingml/2006/main"/>
           <a:p xmlns:a="http://schemas.openxmlformats.org/drawingml/2006/main">
             <a:r>
-              <a:t>Step 3 Check</a:t>
+              <a:t>Step 2: What changed?</a:t>
             </a:r>
             <a:endParaRPr/>
           </a:p>
@@ -6504,7 +7023,7 @@
     </p:spTree>
     <p:extLst>
       <p:ext uri="{BB962C8B-B14F-4D97-AF65-F5344CB8AC3E}">
-        <p14:creationId xmlns:p14="http://schemas.microsoft.com/office/powerpoint/2010/main" val="280098342"/>
+        <p14:creationId xmlns:p14="http://schemas.microsoft.com/office/powerpoint/2010/main" val="1225500577"/>
       </p:ext>
     </p:extLst>
   </p:cSld>
@@ -6528,7 +7047,7 @@
           <p:cNvPr id="2" name="Content Placeholder 2">
             <a:extLst xmlns:a="http://schemas.openxmlformats.org/drawingml/2006/main">
               <a:ext uri="{FF2B5EF4-FFF2-40B4-BE49-F238E27FC236}">
-                <a16:creationId xmlns:a16="http://schemas.microsoft.com/office/drawing/2014/main" id="{D8514CD9-F679-4F74-B9A7-3E0301EE9BCF}"/>
+                <a16:creationId xmlns:a16="http://schemas.microsoft.com/office/drawing/2014/main" id="{EB77854E-AE38-4EF5-B06D-8B262A2FE515}"/>
               </a:ext>
             </a:extLst>
           </p:cNvPr>
@@ -6548,7 +7067,7 @@
               <a:buNone/>
             </a:pPr>
             <a:r>
-              <a:t>Load when the BOM page appears.</a:t>
+              <a:t>A failed write must not leave a false row.</a:t>
             </a:r>
           </a:p>
           <a:p xmlns:a="http://schemas.openxmlformats.org/drawingml/2006/main">
@@ -6556,7 +7075,7 @@
               <a:buNone/>
             </a:pPr>
             <a:r>
-              <a:t>Use FileSystem.AppDataDirectory for the path.</a:t>
+              <a:t>Restore the collection after an error.</a:t>
             </a:r>
           </a:p>
         </p:txBody>
@@ -6589,7 +7108,7 @@
           <a:lstStyle xmlns:a="http://schemas.openxmlformats.org/drawingml/2006/main"/>
           <a:p xmlns:a="http://schemas.openxmlformats.org/drawingml/2006/main">
             <a:r>
-              <a:t>Step 4 Page lifecycle</a:t>
+              <a:t>Step 3: Failed save</a:t>
             </a:r>
             <a:endParaRPr/>
           </a:p>
@@ -6598,7 +7117,7 @@
     </p:spTree>
     <p:extLst>
       <p:ext uri="{BB962C8B-B14F-4D97-AF65-F5344CB8AC3E}">
-        <p14:creationId xmlns:p14="http://schemas.microsoft.com/office/powerpoint/2010/main" val="1589783001"/>
+        <p14:creationId xmlns:p14="http://schemas.microsoft.com/office/powerpoint/2010/main" val="1242161928"/>
       </p:ext>
     </p:extLst>
   </p:cSld>

</xml_diff>